<commit_message>
docs: remove fourth prior-art item from patent presentation
</commit_message>
<xml_diff>
--- a/docs/patents/nasus-art-v2/presentation/Nasus_专利申请评审_9页_20261029_v2.pptx
+++ b/docs/patents/nasus-art-v2/presentation/Nasus_专利申请评审_9页_20261029_v2.pptx
@@ -572,11 +572,6 @@
           </a:p>
           <a:p xmlns:a="http://schemas.openxmlformats.org/drawingml/2006/main">
             <a:r>
-              <a:t>4. 基于依赖分析的回归测试选择（RTS）：依据静态或动态依赖及历史运行覆盖，确定已有测试中哪些需要在变更后重新执行。关系或依赖需随版本更新；选择已有测试本身不负责生成尚不存在的用例。Ekstazi对没有历史依赖信息的新测试会执行，不应描述成新增测试一律被遗漏。</a:t>
-            </a:r>
-          </a:p>
-          <a:p xmlns:a="http://schemas.openxmlformats.org/drawingml/2006/main">
-            <a:r>
               <a:t>下列公开资料支持技术能力的说明。局限性是上述适用条件下的工程分析，不将其归结为来源资料或全部现有产品的统一结论。</a:t>
             </a:r>
           </a:p>
@@ -613,16 +608,6 @@
           <a:p xmlns:a="http://schemas.openxmlformats.org/drawingml/2006/main">
             <a:r>
               <a:t>[M5] Lewis et al., Retrieval-Augmented Generation for Knowledge-Intensive NLP Tasks, 2020. https://arxiv.org/abs/2005.11401</a:t>
-            </a:r>
-          </a:p>
-          <a:p xmlns:a="http://schemas.openxmlformats.org/drawingml/2006/main">
-            <a:r>
-              <a:t>[M6] Gligoric, Regression Test Selection: Theory and Practice, 2015. https://users.ece.utexas.edu/~gligoric/papers/Gligoric15PhD.pdf</a:t>
-            </a:r>
-          </a:p>
-          <a:p xmlns:a="http://schemas.openxmlformats.org/drawingml/2006/main">
-            <a:r>
-              <a:t>[M7] Ekstazi official repository. https://github.com/gliga/ekstazi</a:t>
             </a:r>
           </a:p>
         </p:txBody>
@@ -11531,7 +11516,7 @@
                   </a:tcPr>
                 </a:tc>
               </a:tr>
-              <a:tr h="1181100">
+              <a:tr h="1574800">
                 <a:tc>
                   <a:txBody>
                     <a:bodyPr/>
@@ -11594,7 +11579,7 @@
                       </a:r>
                     </a:p>
                   </a:txBody>
-                  <a:tcPr marL="209550" marR="190500" marT="95250" marB="76200" anchor="t">
+                  <a:tcPr marL="209550" marR="190500" marT="95250" marB="76200" anchor="ctr">
                     <a:lnL w="9525">
                       <a:solidFill>
                         <a:srgbClr val="DCE4E9"/>
@@ -11680,7 +11665,7 @@
                       </a:r>
                     </a:p>
                   </a:txBody>
-                  <a:tcPr marL="209550" marR="190500" marT="95250" marB="76200" anchor="t">
+                  <a:tcPr marL="209550" marR="190500" marT="95250" marB="76200" anchor="ctr">
                     <a:lnR w="9525">
                       <a:solidFill>
                         <a:srgbClr val="DCE4E9"/>
@@ -11699,7 +11684,7 @@
                   </a:tcPr>
                 </a:tc>
               </a:tr>
-              <a:tr h="1181100">
+              <a:tr h="1574800">
                 <a:tc>
                   <a:txBody>
                     <a:bodyPr/>
@@ -11762,7 +11747,7 @@
                       </a:r>
                     </a:p>
                   </a:txBody>
-                  <a:tcPr marL="209550" marR="190500" marT="95250" marB="76200" anchor="t">
+                  <a:tcPr marL="209550" marR="190500" marT="95250" marB="76200" anchor="ctr">
                     <a:lnL w="9525">
                       <a:solidFill>
                         <a:srgbClr val="DCE4E9"/>
@@ -11848,7 +11833,7 @@
                       </a:r>
                     </a:p>
                   </a:txBody>
-                  <a:tcPr marL="209550" marR="190500" marT="95250" marB="76200" anchor="t">
+                  <a:tcPr marL="209550" marR="190500" marT="95250" marB="76200" anchor="ctr">
                     <a:lnR w="9525">
                       <a:solidFill>
                         <a:srgbClr val="DCE4E9"/>
@@ -11867,7 +11852,7 @@
                   </a:tcPr>
                 </a:tc>
               </a:tr>
-              <a:tr h="1181100">
+              <a:tr h="1574800">
                 <a:tc>
                   <a:txBody>
                     <a:bodyPr/>
@@ -11930,7 +11915,7 @@
                       </a:r>
                     </a:p>
                   </a:txBody>
-                  <a:tcPr marL="209550" marR="190500" marT="95250" marB="76200" anchor="t">
+                  <a:tcPr marL="209550" marR="190500" marT="95250" marB="76200" anchor="ctr">
                     <a:lnL w="9525">
                       <a:solidFill>
                         <a:srgbClr val="DCE4E9"/>
@@ -12016,7 +12001,7 @@
                       </a:r>
                     </a:p>
                   </a:txBody>
-                  <a:tcPr marL="209550" marR="190500" marT="95250" marB="76200" anchor="t">
+                  <a:tcPr marL="209550" marR="190500" marT="95250" marB="76200" anchor="ctr">
                     <a:lnR w="9525">
                       <a:solidFill>
                         <a:srgbClr val="DCE4E9"/>
@@ -12031,174 +12016,6 @@
                     </a:lnB>
                     <a:solidFill>
                       <a:srgbClr val="FFFFFF"/>
-                    </a:solidFill>
-                  </a:tcPr>
-                </a:tc>
-              </a:tr>
-              <a:tr h="1181100">
-                <a:tc>
-                  <a:txBody>
-                    <a:bodyPr/>
-                    <a:lstStyle/>
-                    <a:p>
-                      <a:pPr>
-                        <a:spcAft>
-                          <a:spcPts val="2"/>
-                        </a:spcAft>
-                        <a:buNone/>
-                      </a:pPr>
-                      <a:r>
-                        <a:rPr sz="2025" b="1">
-                          <a:solidFill>
-                            <a:srgbClr val="102C43"/>
-                          </a:solidFill>
-                          <a:latin typeface="Arial Unicode MS"/>
-                          <a:ea typeface="Arial Unicode MS"/>
-                          <a:cs typeface="Arial Unicode MS"/>
-                        </a:rPr>
-                        <a:t>基于依赖分析的回归测试选择</a:t>
-                      </a:r>
-                    </a:p>
-                    <a:p>
-                      <a:pPr>
-                        <a:spcAft>
-                          <a:spcPts val="2"/>
-                        </a:spcAft>
-                        <a:buNone/>
-                      </a:pPr>
-                      <a:r>
-                        <a:rPr sz="2025" b="1">
-                          <a:solidFill>
-                            <a:srgbClr val="102C43"/>
-                          </a:solidFill>
-                          <a:latin typeface="Arial Unicode MS"/>
-                          <a:ea typeface="Arial Unicode MS"/>
-                          <a:cs typeface="Arial Unicode MS"/>
-                        </a:rPr>
-                        <a:t>依据代码依赖或历史覆盖关系，</a:t>
-                      </a:r>
-                    </a:p>
-                    <a:p>
-                      <a:pPr>
-                        <a:spcAft>
-                          <a:spcPts val="2"/>
-                        </a:spcAft>
-                        <a:buNone/>
-                      </a:pPr>
-                      <a:r>
-                        <a:rPr sz="2025" b="1">
-                          <a:solidFill>
-                            <a:srgbClr val="102C43"/>
-                          </a:solidFill>
-                          <a:latin typeface="Arial Unicode MS"/>
-                          <a:ea typeface="Arial Unicode MS"/>
-                          <a:cs typeface="Arial Unicode MS"/>
-                        </a:rPr>
-                        <a:t>选择受变更影响的已有测试重新执行。</a:t>
-                      </a:r>
-                    </a:p>
-                  </a:txBody>
-                  <a:tcPr marL="209550" marR="190500" marT="95250" marB="76200" anchor="t">
-                    <a:lnL w="9525">
-                      <a:solidFill>
-                        <a:srgbClr val="DCE4E9"/>
-                      </a:solidFill>
-                      <a:prstDash val="solid"/>
-                    </a:lnL>
-                    <a:lnR w="9525">
-                      <a:solidFill>
-                        <a:srgbClr val="DCE4E9"/>
-                      </a:solidFill>
-                      <a:prstDash val="solid"/>
-                    </a:lnR>
-                    <a:lnB w="9525">
-                      <a:solidFill>
-                        <a:srgbClr val="DCE4E9"/>
-                      </a:solidFill>
-                      <a:prstDash val="solid"/>
-                    </a:lnB>
-                    <a:solidFill>
-                      <a:srgbClr val="EDF4F6"/>
-                    </a:solidFill>
-                  </a:tcPr>
-                </a:tc>
-                <a:tc>
-                  <a:txBody>
-                    <a:bodyPr/>
-                    <a:lstStyle/>
-                    <a:p>
-                      <a:pPr>
-                        <a:spcAft>
-                          <a:spcPts val="2"/>
-                        </a:spcAft>
-                        <a:buNone/>
-                      </a:pPr>
-                      <a:r>
-                        <a:rPr sz="2025" b="1">
-                          <a:solidFill>
-                            <a:srgbClr val="A35220"/>
-                          </a:solidFill>
-                          <a:latin typeface="Arial Unicode MS"/>
-                          <a:ea typeface="Arial Unicode MS"/>
-                          <a:cs typeface="Arial Unicode MS"/>
-                        </a:rPr>
-                        <a:t>依赖需要更新，选择范围受已有用例限制</a:t>
-                      </a:r>
-                    </a:p>
-                    <a:p>
-                      <a:pPr>
-                        <a:spcAft>
-                          <a:spcPts val="2"/>
-                        </a:spcAft>
-                        <a:buNone/>
-                      </a:pPr>
-                      <a:r>
-                        <a:rPr sz="2025" b="1">
-                          <a:solidFill>
-                            <a:srgbClr val="A35220"/>
-                          </a:solidFill>
-                          <a:latin typeface="Arial Unicode MS"/>
-                          <a:ea typeface="Arial Unicode MS"/>
-                          <a:cs typeface="Arial Unicode MS"/>
-                        </a:rPr>
-                        <a:t>依赖变化后，需要更新测试选择的依据。</a:t>
-                      </a:r>
-                    </a:p>
-                    <a:p>
-                      <a:pPr>
-                        <a:spcAft>
-                          <a:spcPts val="2"/>
-                        </a:spcAft>
-                        <a:buNone/>
-                      </a:pPr>
-                      <a:r>
-                        <a:rPr sz="2025" b="1">
-                          <a:solidFill>
-                            <a:srgbClr val="A35220"/>
-                          </a:solidFill>
-                          <a:latin typeface="Arial Unicode MS"/>
-                          <a:ea typeface="Arial Unicode MS"/>
-                          <a:cs typeface="Arial Unicode MS"/>
-                        </a:rPr>
-                        <a:t>仅选择已有用例，不能补齐尚未编写的必要测试。</a:t>
-                      </a:r>
-                    </a:p>
-                  </a:txBody>
-                  <a:tcPr marL="209550" marR="190500" marT="95250" marB="76200" anchor="t">
-                    <a:lnR w="9525">
-                      <a:solidFill>
-                        <a:srgbClr val="DCE4E9"/>
-                      </a:solidFill>
-                      <a:prstDash val="solid"/>
-                    </a:lnR>
-                    <a:lnB w="9525">
-                      <a:solidFill>
-                        <a:srgbClr val="DCE4E9"/>
-                      </a:solidFill>
-                      <a:prstDash val="solid"/>
-                    </a:lnB>
-                    <a:solidFill>
-                      <a:srgbClr val="EDF4F6"/>
                     </a:solidFill>
                   </a:tcPr>
                 </a:tc>

</xml_diff>

<commit_message>
docs: use white background on patent presentation opening slide
</commit_message>
<xml_diff>
--- a/docs/patents/nasus-art-v2/presentation/Nasus_专利申请评审_9页_20261029_v2.pptx
+++ b/docs/patents/nasus-art-v2/presentation/Nasus_专利申请评审_9页_20261029_v2.pptx
@@ -4268,7 +4268,7 @@
     <p:bg>
       <p:bgPr>
         <a:solidFill xmlns:a="http://schemas.openxmlformats.org/drawingml/2006/main">
-          <a:srgbClr val="102C43"/>
+          <a:srgbClr val="FFFFFF"/>
         </a:solidFill>
       </p:bgPr>
     </p:bg>
@@ -4306,7 +4306,7 @@
           </a:prstGeom>
           <a:ln xmlns:a="http://schemas.openxmlformats.org/drawingml/2006/main" w="19050">
             <a:solidFill>
-              <a:srgbClr val="587386"/>
+              <a:srgbClr val="9BADB8"/>
             </a:solidFill>
             <a:tailEnd type="triangle" w="sm" len="sm"/>
           </a:ln>
@@ -4337,7 +4337,7 @@
           </a:prstGeom>
           <a:ln xmlns:a="http://schemas.openxmlformats.org/drawingml/2006/main" w="19050">
             <a:solidFill>
-              <a:srgbClr val="587386"/>
+              <a:srgbClr val="9BADB8"/>
             </a:solidFill>
             <a:tailEnd type="triangle" w="sm" len="sm"/>
           </a:ln>
@@ -4368,7 +4368,7 @@
           </a:prstGeom>
           <a:ln xmlns:a="http://schemas.openxmlformats.org/drawingml/2006/main" w="19050">
             <a:solidFill>
-              <a:srgbClr val="587386"/>
+              <a:srgbClr val="9BADB8"/>
             </a:solidFill>
             <a:tailEnd type="triangle" w="sm" len="sm"/>
           </a:ln>
@@ -4399,7 +4399,7 @@
           </a:prstGeom>
           <a:ln xmlns:a="http://schemas.openxmlformats.org/drawingml/2006/main" w="19050">
             <a:solidFill>
-              <a:srgbClr val="587386"/>
+              <a:srgbClr val="9BADB8"/>
             </a:solidFill>
             <a:tailEnd type="triangle" w="sm" len="sm"/>
           </a:ln>
@@ -4430,7 +4430,7 @@
           </a:prstGeom>
           <a:ln xmlns:a="http://schemas.openxmlformats.org/drawingml/2006/main" w="19050">
             <a:solidFill>
-              <a:srgbClr val="587386"/>
+              <a:srgbClr val="9BADB8"/>
             </a:solidFill>
             <a:tailEnd type="triangle" w="sm" len="sm"/>
           </a:ln>
@@ -4461,7 +4461,7 @@
           </a:prstGeom>
           <a:ln xmlns:a="http://schemas.openxmlformats.org/drawingml/2006/main" w="19050">
             <a:solidFill>
-              <a:srgbClr val="587386"/>
+              <a:srgbClr val="9BADB8"/>
             </a:solidFill>
             <a:tailEnd type="triangle" w="sm" len="sm"/>
           </a:ln>
@@ -4502,7 +4502,7 @@
             <a:defPPr algn="l">
               <a:defRPr sz="1800" b="1">
                 <a:solidFill>
-                  <a:srgbClr val="81D9D1"/>
+                  <a:srgbClr val="007F83"/>
                 </a:solidFill>
                 <a:latin typeface="Arial Unicode MS"/>
                 <a:ea typeface="Arial Unicode MS"/>
@@ -4513,7 +4513,7 @@
               <a:buNone/>
               <a:defRPr sz="1800" b="1">
                 <a:solidFill>
-                  <a:srgbClr val="81D9D1"/>
+                  <a:srgbClr val="007F83"/>
                 </a:solidFill>
                 <a:latin typeface="Arial Unicode MS"/>
                 <a:ea typeface="Arial Unicode MS"/>
@@ -4524,7 +4524,7 @@
               <a:buNone/>
               <a:defRPr sz="1800" b="1">
                 <a:solidFill>
-                  <a:srgbClr val="81D9D1"/>
+                  <a:srgbClr val="007F83"/>
                 </a:solidFill>
                 <a:latin typeface="Arial Unicode MS"/>
                 <a:ea typeface="Arial Unicode MS"/>
@@ -4535,7 +4535,7 @@
               <a:buNone/>
               <a:defRPr sz="1800" b="1">
                 <a:solidFill>
-                  <a:srgbClr val="81D9D1"/>
+                  <a:srgbClr val="007F83"/>
                 </a:solidFill>
                 <a:latin typeface="Arial Unicode MS"/>
                 <a:ea typeface="Arial Unicode MS"/>
@@ -4546,7 +4546,7 @@
               <a:buNone/>
               <a:defRPr sz="1800" b="1">
                 <a:solidFill>
-                  <a:srgbClr val="81D9D1"/>
+                  <a:srgbClr val="007F83"/>
                 </a:solidFill>
                 <a:latin typeface="Arial Unicode MS"/>
                 <a:ea typeface="Arial Unicode MS"/>
@@ -4557,7 +4557,7 @@
               <a:buNone/>
               <a:defRPr sz="1800" b="1">
                 <a:solidFill>
-                  <a:srgbClr val="81D9D1"/>
+                  <a:srgbClr val="007F83"/>
                 </a:solidFill>
                 <a:latin typeface="Arial Unicode MS"/>
                 <a:ea typeface="Arial Unicode MS"/>
@@ -4568,7 +4568,7 @@
               <a:buNone/>
               <a:defRPr sz="1800" b="1">
                 <a:solidFill>
-                  <a:srgbClr val="81D9D1"/>
+                  <a:srgbClr val="007F83"/>
                 </a:solidFill>
                 <a:latin typeface="Arial Unicode MS"/>
                 <a:ea typeface="Arial Unicode MS"/>
@@ -4579,7 +4579,7 @@
               <a:buNone/>
               <a:defRPr sz="1800" b="1">
                 <a:solidFill>
-                  <a:srgbClr val="81D9D1"/>
+                  <a:srgbClr val="007F83"/>
                 </a:solidFill>
                 <a:latin typeface="Arial Unicode MS"/>
                 <a:ea typeface="Arial Unicode MS"/>
@@ -4590,7 +4590,7 @@
               <a:buNone/>
               <a:defRPr sz="1800" b="1">
                 <a:solidFill>
-                  <a:srgbClr val="81D9D1"/>
+                  <a:srgbClr val="007F83"/>
                 </a:solidFill>
                 <a:latin typeface="Arial Unicode MS"/>
                 <a:ea typeface="Arial Unicode MS"/>
@@ -4601,7 +4601,7 @@
               <a:buNone/>
               <a:defRPr sz="1800" b="1">
                 <a:solidFill>
-                  <a:srgbClr val="81D9D1"/>
+                  <a:srgbClr val="007F83"/>
                 </a:solidFill>
                 <a:latin typeface="Arial Unicode MS"/>
                 <a:ea typeface="Arial Unicode MS"/>
@@ -4614,7 +4614,7 @@
               <a:buNone/>
               <a:defRPr sz="1800" b="1">
                 <a:solidFill>
-                  <a:srgbClr val="81D9D1"/>
+                  <a:srgbClr val="007F83"/>
                 </a:solidFill>
                 <a:latin typeface="Arial Unicode MS"/>
                 <a:ea typeface="Arial Unicode MS"/>
@@ -4624,7 +4624,7 @@
             <a:r>
               <a:rPr sz="1800" b="1">
                 <a:solidFill>
-                  <a:srgbClr val="81D9D1"/>
+                  <a:srgbClr val="007F83"/>
                 </a:solidFill>
                 <a:latin typeface="Arial Unicode MS"/>
                 <a:ea typeface="Arial Unicode MS"/>
@@ -4670,7 +4670,7 @@
             <a:defPPr algn="l">
               <a:defRPr sz="3600" b="1">
                 <a:solidFill>
-                  <a:srgbClr val="FFFFFF"/>
+                  <a:srgbClr val="102C43"/>
                 </a:solidFill>
                 <a:latin typeface="Arial Unicode MS"/>
                 <a:ea typeface="Arial Unicode MS"/>
@@ -4681,7 +4681,7 @@
               <a:buNone/>
               <a:defRPr sz="3600" b="1">
                 <a:solidFill>
-                  <a:srgbClr val="FFFFFF"/>
+                  <a:srgbClr val="102C43"/>
                 </a:solidFill>
                 <a:latin typeface="Arial Unicode MS"/>
                 <a:ea typeface="Arial Unicode MS"/>
@@ -4692,7 +4692,7 @@
               <a:buNone/>
               <a:defRPr sz="3600" b="1">
                 <a:solidFill>
-                  <a:srgbClr val="FFFFFF"/>
+                  <a:srgbClr val="102C43"/>
                 </a:solidFill>
                 <a:latin typeface="Arial Unicode MS"/>
                 <a:ea typeface="Arial Unicode MS"/>
@@ -4703,7 +4703,7 @@
               <a:buNone/>
               <a:defRPr sz="3600" b="1">
                 <a:solidFill>
-                  <a:srgbClr val="FFFFFF"/>
+                  <a:srgbClr val="102C43"/>
                 </a:solidFill>
                 <a:latin typeface="Arial Unicode MS"/>
                 <a:ea typeface="Arial Unicode MS"/>
@@ -4714,7 +4714,7 @@
               <a:buNone/>
               <a:defRPr sz="3600" b="1">
                 <a:solidFill>
-                  <a:srgbClr val="FFFFFF"/>
+                  <a:srgbClr val="102C43"/>
                 </a:solidFill>
                 <a:latin typeface="Arial Unicode MS"/>
                 <a:ea typeface="Arial Unicode MS"/>
@@ -4725,7 +4725,7 @@
               <a:buNone/>
               <a:defRPr sz="3600" b="1">
                 <a:solidFill>
-                  <a:srgbClr val="FFFFFF"/>
+                  <a:srgbClr val="102C43"/>
                 </a:solidFill>
                 <a:latin typeface="Arial Unicode MS"/>
                 <a:ea typeface="Arial Unicode MS"/>
@@ -4736,7 +4736,7 @@
               <a:buNone/>
               <a:defRPr sz="3600" b="1">
                 <a:solidFill>
-                  <a:srgbClr val="FFFFFF"/>
+                  <a:srgbClr val="102C43"/>
                 </a:solidFill>
                 <a:latin typeface="Arial Unicode MS"/>
                 <a:ea typeface="Arial Unicode MS"/>
@@ -4747,7 +4747,7 @@
               <a:buNone/>
               <a:defRPr sz="3600" b="1">
                 <a:solidFill>
-                  <a:srgbClr val="FFFFFF"/>
+                  <a:srgbClr val="102C43"/>
                 </a:solidFill>
                 <a:latin typeface="Arial Unicode MS"/>
                 <a:ea typeface="Arial Unicode MS"/>
@@ -4758,7 +4758,7 @@
               <a:buNone/>
               <a:defRPr sz="3600" b="1">
                 <a:solidFill>
-                  <a:srgbClr val="FFFFFF"/>
+                  <a:srgbClr val="102C43"/>
                 </a:solidFill>
                 <a:latin typeface="Arial Unicode MS"/>
                 <a:ea typeface="Arial Unicode MS"/>
@@ -4769,7 +4769,7 @@
               <a:buNone/>
               <a:defRPr sz="3600" b="1">
                 <a:solidFill>
-                  <a:srgbClr val="FFFFFF"/>
+                  <a:srgbClr val="102C43"/>
                 </a:solidFill>
                 <a:latin typeface="Arial Unicode MS"/>
                 <a:ea typeface="Arial Unicode MS"/>
@@ -4782,7 +4782,7 @@
               <a:buNone/>
               <a:defRPr sz="3600" b="1">
                 <a:solidFill>
-                  <a:srgbClr val="FFFFFF"/>
+                  <a:srgbClr val="102C43"/>
                 </a:solidFill>
                 <a:latin typeface="Arial Unicode MS"/>
                 <a:ea typeface="Arial Unicode MS"/>
@@ -4792,7 +4792,7 @@
             <a:r>
               <a:rPr sz="3600" b="1">
                 <a:solidFill>
-                  <a:srgbClr val="FFFFFF"/>
+                  <a:srgbClr val="102C43"/>
                 </a:solidFill>
                 <a:latin typeface="Arial Unicode MS"/>
                 <a:ea typeface="Arial Unicode MS"/>
@@ -4838,7 +4838,7 @@
             <a:defPPr algn="l">
               <a:defRPr sz="2175" b="0">
                 <a:solidFill>
-                  <a:srgbClr val="DCEAF1"/>
+                  <a:srgbClr val="203849"/>
                 </a:solidFill>
                 <a:latin typeface="Arial Unicode MS"/>
                 <a:ea typeface="Arial Unicode MS"/>
@@ -4849,7 +4849,7 @@
               <a:buNone/>
               <a:defRPr sz="2175" b="0">
                 <a:solidFill>
-                  <a:srgbClr val="DCEAF1"/>
+                  <a:srgbClr val="203849"/>
                 </a:solidFill>
                 <a:latin typeface="Arial Unicode MS"/>
                 <a:ea typeface="Arial Unicode MS"/>
@@ -4860,7 +4860,7 @@
               <a:buNone/>
               <a:defRPr sz="2175" b="0">
                 <a:solidFill>
-                  <a:srgbClr val="DCEAF1"/>
+                  <a:srgbClr val="203849"/>
                 </a:solidFill>
                 <a:latin typeface="Arial Unicode MS"/>
                 <a:ea typeface="Arial Unicode MS"/>
@@ -4871,7 +4871,7 @@
               <a:buNone/>
               <a:defRPr sz="2175" b="0">
                 <a:solidFill>
-                  <a:srgbClr val="DCEAF1"/>
+                  <a:srgbClr val="203849"/>
                 </a:solidFill>
                 <a:latin typeface="Arial Unicode MS"/>
                 <a:ea typeface="Arial Unicode MS"/>
@@ -4882,7 +4882,7 @@
               <a:buNone/>
               <a:defRPr sz="2175" b="0">
                 <a:solidFill>
-                  <a:srgbClr val="DCEAF1"/>
+                  <a:srgbClr val="203849"/>
                 </a:solidFill>
                 <a:latin typeface="Arial Unicode MS"/>
                 <a:ea typeface="Arial Unicode MS"/>
@@ -4893,7 +4893,7 @@
               <a:buNone/>
               <a:defRPr sz="2175" b="0">
                 <a:solidFill>
-                  <a:srgbClr val="DCEAF1"/>
+                  <a:srgbClr val="203849"/>
                 </a:solidFill>
                 <a:latin typeface="Arial Unicode MS"/>
                 <a:ea typeface="Arial Unicode MS"/>
@@ -4904,7 +4904,7 @@
               <a:buNone/>
               <a:defRPr sz="2175" b="0">
                 <a:solidFill>
-                  <a:srgbClr val="DCEAF1"/>
+                  <a:srgbClr val="203849"/>
                 </a:solidFill>
                 <a:latin typeface="Arial Unicode MS"/>
                 <a:ea typeface="Arial Unicode MS"/>
@@ -4915,7 +4915,7 @@
               <a:buNone/>
               <a:defRPr sz="2175" b="0">
                 <a:solidFill>
-                  <a:srgbClr val="DCEAF1"/>
+                  <a:srgbClr val="203849"/>
                 </a:solidFill>
                 <a:latin typeface="Arial Unicode MS"/>
                 <a:ea typeface="Arial Unicode MS"/>
@@ -4926,7 +4926,7 @@
               <a:buNone/>
               <a:defRPr sz="2175" b="0">
                 <a:solidFill>
-                  <a:srgbClr val="DCEAF1"/>
+                  <a:srgbClr val="203849"/>
                 </a:solidFill>
                 <a:latin typeface="Arial Unicode MS"/>
                 <a:ea typeface="Arial Unicode MS"/>
@@ -4937,7 +4937,7 @@
               <a:buNone/>
               <a:defRPr sz="2175" b="0">
                 <a:solidFill>
-                  <a:srgbClr val="DCEAF1"/>
+                  <a:srgbClr val="203849"/>
                 </a:solidFill>
                 <a:latin typeface="Arial Unicode MS"/>
                 <a:ea typeface="Arial Unicode MS"/>
@@ -4950,7 +4950,7 @@
               <a:buNone/>
               <a:defRPr sz="2175" b="0">
                 <a:solidFill>
-                  <a:srgbClr val="DCEAF1"/>
+                  <a:srgbClr val="203849"/>
                 </a:solidFill>
                 <a:latin typeface="Arial Unicode MS"/>
                 <a:ea typeface="Arial Unicode MS"/>
@@ -4960,7 +4960,7 @@
             <a:r>
               <a:rPr sz="2175" b="0">
                 <a:solidFill>
-                  <a:srgbClr val="DCEAF1"/>
+                  <a:srgbClr val="203849"/>
                 </a:solidFill>
                 <a:latin typeface="Arial Unicode MS"/>
                 <a:ea typeface="Arial Unicode MS"/>
@@ -5006,7 +5006,7 @@
             <a:defPPr algn="l">
               <a:defRPr sz="1800" b="1">
                 <a:solidFill>
-                  <a:srgbClr val="81D9D1"/>
+                  <a:srgbClr val="007F83"/>
                 </a:solidFill>
                 <a:latin typeface="Arial Unicode MS"/>
                 <a:ea typeface="Arial Unicode MS"/>
@@ -5017,7 +5017,7 @@
               <a:buNone/>
               <a:defRPr sz="1800" b="1">
                 <a:solidFill>
-                  <a:srgbClr val="81D9D1"/>
+                  <a:srgbClr val="007F83"/>
                 </a:solidFill>
                 <a:latin typeface="Arial Unicode MS"/>
                 <a:ea typeface="Arial Unicode MS"/>
@@ -5028,7 +5028,7 @@
               <a:buNone/>
               <a:defRPr sz="1800" b="1">
                 <a:solidFill>
-                  <a:srgbClr val="81D9D1"/>
+                  <a:srgbClr val="007F83"/>
                 </a:solidFill>
                 <a:latin typeface="Arial Unicode MS"/>
                 <a:ea typeface="Arial Unicode MS"/>
@@ -5039,7 +5039,7 @@
               <a:buNone/>
               <a:defRPr sz="1800" b="1">
                 <a:solidFill>
-                  <a:srgbClr val="81D9D1"/>
+                  <a:srgbClr val="007F83"/>
                 </a:solidFill>
                 <a:latin typeface="Arial Unicode MS"/>
                 <a:ea typeface="Arial Unicode MS"/>
@@ -5050,7 +5050,7 @@
               <a:buNone/>
               <a:defRPr sz="1800" b="1">
                 <a:solidFill>
-                  <a:srgbClr val="81D9D1"/>
+                  <a:srgbClr val="007F83"/>
                 </a:solidFill>
                 <a:latin typeface="Arial Unicode MS"/>
                 <a:ea typeface="Arial Unicode MS"/>
@@ -5061,7 +5061,7 @@
               <a:buNone/>
               <a:defRPr sz="1800" b="1">
                 <a:solidFill>
-                  <a:srgbClr val="81D9D1"/>
+                  <a:srgbClr val="007F83"/>
                 </a:solidFill>
                 <a:latin typeface="Arial Unicode MS"/>
                 <a:ea typeface="Arial Unicode MS"/>
@@ -5072,7 +5072,7 @@
               <a:buNone/>
               <a:defRPr sz="1800" b="1">
                 <a:solidFill>
-                  <a:srgbClr val="81D9D1"/>
+                  <a:srgbClr val="007F83"/>
                 </a:solidFill>
                 <a:latin typeface="Arial Unicode MS"/>
                 <a:ea typeface="Arial Unicode MS"/>
@@ -5083,7 +5083,7 @@
               <a:buNone/>
               <a:defRPr sz="1800" b="1">
                 <a:solidFill>
-                  <a:srgbClr val="81D9D1"/>
+                  <a:srgbClr val="007F83"/>
                 </a:solidFill>
                 <a:latin typeface="Arial Unicode MS"/>
                 <a:ea typeface="Arial Unicode MS"/>
@@ -5094,7 +5094,7 @@
               <a:buNone/>
               <a:defRPr sz="1800" b="1">
                 <a:solidFill>
-                  <a:srgbClr val="81D9D1"/>
+                  <a:srgbClr val="007F83"/>
                 </a:solidFill>
                 <a:latin typeface="Arial Unicode MS"/>
                 <a:ea typeface="Arial Unicode MS"/>
@@ -5105,7 +5105,7 @@
               <a:buNone/>
               <a:defRPr sz="1800" b="1">
                 <a:solidFill>
-                  <a:srgbClr val="81D9D1"/>
+                  <a:srgbClr val="007F83"/>
                 </a:solidFill>
                 <a:latin typeface="Arial Unicode MS"/>
                 <a:ea typeface="Arial Unicode MS"/>
@@ -5118,7 +5118,7 @@
               <a:buNone/>
               <a:defRPr sz="1800" b="1">
                 <a:solidFill>
-                  <a:srgbClr val="81D9D1"/>
+                  <a:srgbClr val="007F83"/>
                 </a:solidFill>
                 <a:latin typeface="Arial Unicode MS"/>
                 <a:ea typeface="Arial Unicode MS"/>
@@ -5128,7 +5128,7 @@
             <a:r>
               <a:rPr sz="1800" b="1">
                 <a:solidFill>
-                  <a:srgbClr val="81D9D1"/>
+                  <a:srgbClr val="007F83"/>
                 </a:solidFill>
                 <a:latin typeface="Arial Unicode MS"/>
                 <a:ea typeface="Arial Unicode MS"/>
@@ -5174,7 +5174,7 @@
             <a:defPPr algn="l">
               <a:defRPr sz="1725" b="0">
                 <a:solidFill>
-                  <a:srgbClr val="EEC28B"/>
+                  <a:srgbClr val="9A641E"/>
                 </a:solidFill>
                 <a:latin typeface="Arial Unicode MS"/>
                 <a:ea typeface="Arial Unicode MS"/>
@@ -5185,7 +5185,7 @@
               <a:buNone/>
               <a:defRPr sz="1725" b="0">
                 <a:solidFill>
-                  <a:srgbClr val="EEC28B"/>
+                  <a:srgbClr val="9A641E"/>
                 </a:solidFill>
                 <a:latin typeface="Arial Unicode MS"/>
                 <a:ea typeface="Arial Unicode MS"/>
@@ -5196,7 +5196,7 @@
               <a:buNone/>
               <a:defRPr sz="1725" b="0">
                 <a:solidFill>
-                  <a:srgbClr val="EEC28B"/>
+                  <a:srgbClr val="9A641E"/>
                 </a:solidFill>
                 <a:latin typeface="Arial Unicode MS"/>
                 <a:ea typeface="Arial Unicode MS"/>
@@ -5207,7 +5207,7 @@
               <a:buNone/>
               <a:defRPr sz="1725" b="0">
                 <a:solidFill>
-                  <a:srgbClr val="EEC28B"/>
+                  <a:srgbClr val="9A641E"/>
                 </a:solidFill>
                 <a:latin typeface="Arial Unicode MS"/>
                 <a:ea typeface="Arial Unicode MS"/>
@@ -5218,7 +5218,7 @@
               <a:buNone/>
               <a:defRPr sz="1725" b="0">
                 <a:solidFill>
-                  <a:srgbClr val="EEC28B"/>
+                  <a:srgbClr val="9A641E"/>
                 </a:solidFill>
                 <a:latin typeface="Arial Unicode MS"/>
                 <a:ea typeface="Arial Unicode MS"/>
@@ -5229,7 +5229,7 @@
               <a:buNone/>
               <a:defRPr sz="1725" b="0">
                 <a:solidFill>
-                  <a:srgbClr val="EEC28B"/>
+                  <a:srgbClr val="9A641E"/>
                 </a:solidFill>
                 <a:latin typeface="Arial Unicode MS"/>
                 <a:ea typeface="Arial Unicode MS"/>
@@ -5240,7 +5240,7 @@
               <a:buNone/>
               <a:defRPr sz="1725" b="0">
                 <a:solidFill>
-                  <a:srgbClr val="EEC28B"/>
+                  <a:srgbClr val="9A641E"/>
                 </a:solidFill>
                 <a:latin typeface="Arial Unicode MS"/>
                 <a:ea typeface="Arial Unicode MS"/>
@@ -5251,7 +5251,7 @@
               <a:buNone/>
               <a:defRPr sz="1725" b="0">
                 <a:solidFill>
-                  <a:srgbClr val="EEC28B"/>
+                  <a:srgbClr val="9A641E"/>
                 </a:solidFill>
                 <a:latin typeface="Arial Unicode MS"/>
                 <a:ea typeface="Arial Unicode MS"/>
@@ -5262,7 +5262,7 @@
               <a:buNone/>
               <a:defRPr sz="1725" b="0">
                 <a:solidFill>
-                  <a:srgbClr val="EEC28B"/>
+                  <a:srgbClr val="9A641E"/>
                 </a:solidFill>
                 <a:latin typeface="Arial Unicode MS"/>
                 <a:ea typeface="Arial Unicode MS"/>
@@ -5273,7 +5273,7 @@
               <a:buNone/>
               <a:defRPr sz="1725" b="0">
                 <a:solidFill>
-                  <a:srgbClr val="EEC28B"/>
+                  <a:srgbClr val="9A641E"/>
                 </a:solidFill>
                 <a:latin typeface="Arial Unicode MS"/>
                 <a:ea typeface="Arial Unicode MS"/>
@@ -5286,7 +5286,7 @@
               <a:buNone/>
               <a:defRPr sz="1725" b="0">
                 <a:solidFill>
-                  <a:srgbClr val="EEC28B"/>
+                  <a:srgbClr val="9A641E"/>
                 </a:solidFill>
                 <a:latin typeface="Arial Unicode MS"/>
                 <a:ea typeface="Arial Unicode MS"/>
@@ -5296,7 +5296,7 @@
             <a:r>
               <a:rPr sz="1725" b="0">
                 <a:solidFill>
-                  <a:srgbClr val="EEC28B"/>
+                  <a:srgbClr val="9A641E"/>
                 </a:solidFill>
                 <a:latin typeface="Arial Unicode MS"/>
                 <a:ea typeface="Arial Unicode MS"/>
@@ -5329,7 +5329,7 @@
           </a:prstGeom>
           <a:ln xmlns:a="http://schemas.openxmlformats.org/drawingml/2006/main" w="28575">
             <a:solidFill>
-              <a:srgbClr val="81D9D1"/>
+              <a:srgbClr val="007F83"/>
             </a:solidFill>
             <a:tailEnd type="none" w="sm" len="sm"/>
           </a:ln>
@@ -5357,7 +5357,7 @@
           </a:prstGeom>
           <a:ln xmlns:a="http://schemas.openxmlformats.org/drawingml/2006/main" w="28575">
             <a:solidFill>
-              <a:srgbClr val="EEC28B"/>
+              <a:srgbClr val="9A641E"/>
             </a:solidFill>
             <a:tailEnd type="none" w="sm" len="sm"/>
           </a:ln>
@@ -5386,11 +5386,11 @@
             <a:avLst/>
           </a:prstGeom>
           <a:solidFill xmlns:a="http://schemas.openxmlformats.org/drawingml/2006/main">
-            <a:srgbClr val="183A53"/>
+            <a:srgbClr val="EAF5F4"/>
           </a:solidFill>
           <a:ln xmlns:a="http://schemas.openxmlformats.org/drawingml/2006/main" w="14288">
             <a:solidFill>
-              <a:srgbClr val="587386"/>
+              <a:srgbClr val="9BADB8"/>
             </a:solidFill>
           </a:ln>
         </p:spPr>
@@ -5430,7 +5430,7 @@
             <a:defPPr algn="ctr">
               <a:defRPr sz="2100" b="1">
                 <a:solidFill>
-                  <a:srgbClr val="FFFFFF"/>
+                  <a:srgbClr val="102C43"/>
                 </a:solidFill>
                 <a:latin typeface="Arial Unicode MS"/>
                 <a:ea typeface="Arial Unicode MS"/>
@@ -5441,7 +5441,7 @@
               <a:buNone/>
               <a:defRPr sz="2100" b="1">
                 <a:solidFill>
-                  <a:srgbClr val="FFFFFF"/>
+                  <a:srgbClr val="102C43"/>
                 </a:solidFill>
                 <a:latin typeface="Arial Unicode MS"/>
                 <a:ea typeface="Arial Unicode MS"/>
@@ -5452,7 +5452,7 @@
               <a:buNone/>
               <a:defRPr sz="2100" b="1">
                 <a:solidFill>
-                  <a:srgbClr val="FFFFFF"/>
+                  <a:srgbClr val="102C43"/>
                 </a:solidFill>
                 <a:latin typeface="Arial Unicode MS"/>
                 <a:ea typeface="Arial Unicode MS"/>
@@ -5463,7 +5463,7 @@
               <a:buNone/>
               <a:defRPr sz="2100" b="1">
                 <a:solidFill>
-                  <a:srgbClr val="FFFFFF"/>
+                  <a:srgbClr val="102C43"/>
                 </a:solidFill>
                 <a:latin typeface="Arial Unicode MS"/>
                 <a:ea typeface="Arial Unicode MS"/>
@@ -5474,7 +5474,7 @@
               <a:buNone/>
               <a:defRPr sz="2100" b="1">
                 <a:solidFill>
-                  <a:srgbClr val="FFFFFF"/>
+                  <a:srgbClr val="102C43"/>
                 </a:solidFill>
                 <a:latin typeface="Arial Unicode MS"/>
                 <a:ea typeface="Arial Unicode MS"/>
@@ -5485,7 +5485,7 @@
               <a:buNone/>
               <a:defRPr sz="2100" b="1">
                 <a:solidFill>
-                  <a:srgbClr val="FFFFFF"/>
+                  <a:srgbClr val="102C43"/>
                 </a:solidFill>
                 <a:latin typeface="Arial Unicode MS"/>
                 <a:ea typeface="Arial Unicode MS"/>
@@ -5496,7 +5496,7 @@
               <a:buNone/>
               <a:defRPr sz="2100" b="1">
                 <a:solidFill>
-                  <a:srgbClr val="FFFFFF"/>
+                  <a:srgbClr val="102C43"/>
                 </a:solidFill>
                 <a:latin typeface="Arial Unicode MS"/>
                 <a:ea typeface="Arial Unicode MS"/>
@@ -5507,7 +5507,7 @@
               <a:buNone/>
               <a:defRPr sz="2100" b="1">
                 <a:solidFill>
-                  <a:srgbClr val="FFFFFF"/>
+                  <a:srgbClr val="102C43"/>
                 </a:solidFill>
                 <a:latin typeface="Arial Unicode MS"/>
                 <a:ea typeface="Arial Unicode MS"/>
@@ -5518,7 +5518,7 @@
               <a:buNone/>
               <a:defRPr sz="2100" b="1">
                 <a:solidFill>
-                  <a:srgbClr val="FFFFFF"/>
+                  <a:srgbClr val="102C43"/>
                 </a:solidFill>
                 <a:latin typeface="Arial Unicode MS"/>
                 <a:ea typeface="Arial Unicode MS"/>
@@ -5529,7 +5529,7 @@
               <a:buNone/>
               <a:defRPr sz="2100" b="1">
                 <a:solidFill>
-                  <a:srgbClr val="FFFFFF"/>
+                  <a:srgbClr val="102C43"/>
                 </a:solidFill>
                 <a:latin typeface="Arial Unicode MS"/>
                 <a:ea typeface="Arial Unicode MS"/>
@@ -5542,7 +5542,7 @@
               <a:buNone/>
               <a:defRPr sz="2100" b="1">
                 <a:solidFill>
-                  <a:srgbClr val="FFFFFF"/>
+                  <a:srgbClr val="102C43"/>
                 </a:solidFill>
                 <a:latin typeface="Arial Unicode MS"/>
                 <a:ea typeface="Arial Unicode MS"/>
@@ -5552,7 +5552,7 @@
             <a:r>
               <a:rPr sz="2100" b="1">
                 <a:solidFill>
-                  <a:srgbClr val="FFFFFF"/>
+                  <a:srgbClr val="102C43"/>
                 </a:solidFill>
                 <a:latin typeface="Arial Unicode MS"/>
                 <a:ea typeface="Arial Unicode MS"/>
@@ -5598,7 +5598,7 @@
             <a:defPPr algn="ctr">
               <a:defRPr sz="1425" b="0">
                 <a:solidFill>
-                  <a:srgbClr val="DCEAF1"/>
+                  <a:srgbClr val="203849"/>
                 </a:solidFill>
                 <a:latin typeface="Arial Unicode MS"/>
                 <a:ea typeface="Arial Unicode MS"/>
@@ -5609,7 +5609,7 @@
               <a:buNone/>
               <a:defRPr sz="1425" b="0">
                 <a:solidFill>
-                  <a:srgbClr val="DCEAF1"/>
+                  <a:srgbClr val="203849"/>
                 </a:solidFill>
                 <a:latin typeface="Arial Unicode MS"/>
                 <a:ea typeface="Arial Unicode MS"/>
@@ -5620,7 +5620,7 @@
               <a:buNone/>
               <a:defRPr sz="1425" b="0">
                 <a:solidFill>
-                  <a:srgbClr val="DCEAF1"/>
+                  <a:srgbClr val="203849"/>
                 </a:solidFill>
                 <a:latin typeface="Arial Unicode MS"/>
                 <a:ea typeface="Arial Unicode MS"/>
@@ -5631,7 +5631,7 @@
               <a:buNone/>
               <a:defRPr sz="1425" b="0">
                 <a:solidFill>
-                  <a:srgbClr val="DCEAF1"/>
+                  <a:srgbClr val="203849"/>
                 </a:solidFill>
                 <a:latin typeface="Arial Unicode MS"/>
                 <a:ea typeface="Arial Unicode MS"/>
@@ -5642,7 +5642,7 @@
               <a:buNone/>
               <a:defRPr sz="1425" b="0">
                 <a:solidFill>
-                  <a:srgbClr val="DCEAF1"/>
+                  <a:srgbClr val="203849"/>
                 </a:solidFill>
                 <a:latin typeface="Arial Unicode MS"/>
                 <a:ea typeface="Arial Unicode MS"/>
@@ -5653,7 +5653,7 @@
               <a:buNone/>
               <a:defRPr sz="1425" b="0">
                 <a:solidFill>
-                  <a:srgbClr val="DCEAF1"/>
+                  <a:srgbClr val="203849"/>
                 </a:solidFill>
                 <a:latin typeface="Arial Unicode MS"/>
                 <a:ea typeface="Arial Unicode MS"/>
@@ -5664,7 +5664,7 @@
               <a:buNone/>
               <a:defRPr sz="1425" b="0">
                 <a:solidFill>
-                  <a:srgbClr val="DCEAF1"/>
+                  <a:srgbClr val="203849"/>
                 </a:solidFill>
                 <a:latin typeface="Arial Unicode MS"/>
                 <a:ea typeface="Arial Unicode MS"/>
@@ -5675,7 +5675,7 @@
               <a:buNone/>
               <a:defRPr sz="1425" b="0">
                 <a:solidFill>
-                  <a:srgbClr val="DCEAF1"/>
+                  <a:srgbClr val="203849"/>
                 </a:solidFill>
                 <a:latin typeface="Arial Unicode MS"/>
                 <a:ea typeface="Arial Unicode MS"/>
@@ -5686,7 +5686,7 @@
               <a:buNone/>
               <a:defRPr sz="1425" b="0">
                 <a:solidFill>
-                  <a:srgbClr val="DCEAF1"/>
+                  <a:srgbClr val="203849"/>
                 </a:solidFill>
                 <a:latin typeface="Arial Unicode MS"/>
                 <a:ea typeface="Arial Unicode MS"/>
@@ -5697,7 +5697,7 @@
               <a:buNone/>
               <a:defRPr sz="1425" b="0">
                 <a:solidFill>
-                  <a:srgbClr val="DCEAF1"/>
+                  <a:srgbClr val="203849"/>
                 </a:solidFill>
                 <a:latin typeface="Arial Unicode MS"/>
                 <a:ea typeface="Arial Unicode MS"/>
@@ -5710,7 +5710,7 @@
               <a:buNone/>
               <a:defRPr sz="1425" b="0">
                 <a:solidFill>
-                  <a:srgbClr val="DCEAF1"/>
+                  <a:srgbClr val="203849"/>
                 </a:solidFill>
                 <a:latin typeface="Arial Unicode MS"/>
                 <a:ea typeface="Arial Unicode MS"/>
@@ -5720,7 +5720,7 @@
             <a:r>
               <a:rPr sz="1425" b="0">
                 <a:solidFill>
-                  <a:srgbClr val="DCEAF1"/>
+                  <a:srgbClr val="203849"/>
                 </a:solidFill>
                 <a:latin typeface="Arial Unicode MS"/>
                 <a:ea typeface="Arial Unicode MS"/>
@@ -5754,11 +5754,11 @@
             <a:avLst/>
           </a:prstGeom>
           <a:solidFill xmlns:a="http://schemas.openxmlformats.org/drawingml/2006/main">
-            <a:srgbClr val="183A53"/>
+            <a:srgbClr val="EAF5F4"/>
           </a:solidFill>
           <a:ln xmlns:a="http://schemas.openxmlformats.org/drawingml/2006/main" w="14288">
             <a:solidFill>
-              <a:srgbClr val="587386"/>
+              <a:srgbClr val="9BADB8"/>
             </a:solidFill>
           </a:ln>
         </p:spPr>
@@ -5798,7 +5798,7 @@
             <a:defPPr algn="ctr">
               <a:defRPr sz="2100" b="1">
                 <a:solidFill>
-                  <a:srgbClr val="FFFFFF"/>
+                  <a:srgbClr val="102C43"/>
                 </a:solidFill>
                 <a:latin typeface="Arial Unicode MS"/>
                 <a:ea typeface="Arial Unicode MS"/>
@@ -5809,7 +5809,7 @@
               <a:buNone/>
               <a:defRPr sz="2100" b="1">
                 <a:solidFill>
-                  <a:srgbClr val="FFFFFF"/>
+                  <a:srgbClr val="102C43"/>
                 </a:solidFill>
                 <a:latin typeface="Arial Unicode MS"/>
                 <a:ea typeface="Arial Unicode MS"/>
@@ -5820,7 +5820,7 @@
               <a:buNone/>
               <a:defRPr sz="2100" b="1">
                 <a:solidFill>
-                  <a:srgbClr val="FFFFFF"/>
+                  <a:srgbClr val="102C43"/>
                 </a:solidFill>
                 <a:latin typeface="Arial Unicode MS"/>
                 <a:ea typeface="Arial Unicode MS"/>
@@ -5831,7 +5831,7 @@
               <a:buNone/>
               <a:defRPr sz="2100" b="1">
                 <a:solidFill>
-                  <a:srgbClr val="FFFFFF"/>
+                  <a:srgbClr val="102C43"/>
                 </a:solidFill>
                 <a:latin typeface="Arial Unicode MS"/>
                 <a:ea typeface="Arial Unicode MS"/>
@@ -5842,7 +5842,7 @@
               <a:buNone/>
               <a:defRPr sz="2100" b="1">
                 <a:solidFill>
-                  <a:srgbClr val="FFFFFF"/>
+                  <a:srgbClr val="102C43"/>
                 </a:solidFill>
                 <a:latin typeface="Arial Unicode MS"/>
                 <a:ea typeface="Arial Unicode MS"/>
@@ -5853,7 +5853,7 @@
               <a:buNone/>
               <a:defRPr sz="2100" b="1">
                 <a:solidFill>
-                  <a:srgbClr val="FFFFFF"/>
+                  <a:srgbClr val="102C43"/>
                 </a:solidFill>
                 <a:latin typeface="Arial Unicode MS"/>
                 <a:ea typeface="Arial Unicode MS"/>
@@ -5864,7 +5864,7 @@
               <a:buNone/>
               <a:defRPr sz="2100" b="1">
                 <a:solidFill>
-                  <a:srgbClr val="FFFFFF"/>
+                  <a:srgbClr val="102C43"/>
                 </a:solidFill>
                 <a:latin typeface="Arial Unicode MS"/>
                 <a:ea typeface="Arial Unicode MS"/>
@@ -5875,7 +5875,7 @@
               <a:buNone/>
               <a:defRPr sz="2100" b="1">
                 <a:solidFill>
-                  <a:srgbClr val="FFFFFF"/>
+                  <a:srgbClr val="102C43"/>
                 </a:solidFill>
                 <a:latin typeface="Arial Unicode MS"/>
                 <a:ea typeface="Arial Unicode MS"/>
@@ -5886,7 +5886,7 @@
               <a:buNone/>
               <a:defRPr sz="2100" b="1">
                 <a:solidFill>
-                  <a:srgbClr val="FFFFFF"/>
+                  <a:srgbClr val="102C43"/>
                 </a:solidFill>
                 <a:latin typeface="Arial Unicode MS"/>
                 <a:ea typeface="Arial Unicode MS"/>
@@ -5897,7 +5897,7 @@
               <a:buNone/>
               <a:defRPr sz="2100" b="1">
                 <a:solidFill>
-                  <a:srgbClr val="FFFFFF"/>
+                  <a:srgbClr val="102C43"/>
                 </a:solidFill>
                 <a:latin typeface="Arial Unicode MS"/>
                 <a:ea typeface="Arial Unicode MS"/>
@@ -5910,7 +5910,7 @@
               <a:buNone/>
               <a:defRPr sz="2100" b="1">
                 <a:solidFill>
-                  <a:srgbClr val="FFFFFF"/>
+                  <a:srgbClr val="102C43"/>
                 </a:solidFill>
                 <a:latin typeface="Arial Unicode MS"/>
                 <a:ea typeface="Arial Unicode MS"/>
@@ -5920,7 +5920,7 @@
             <a:r>
               <a:rPr sz="2100" b="1">
                 <a:solidFill>
-                  <a:srgbClr val="FFFFFF"/>
+                  <a:srgbClr val="102C43"/>
                 </a:solidFill>
                 <a:latin typeface="Arial Unicode MS"/>
                 <a:ea typeface="Arial Unicode MS"/>
@@ -5966,7 +5966,7 @@
             <a:defPPr algn="ctr">
               <a:defRPr sz="1425" b="0">
                 <a:solidFill>
-                  <a:srgbClr val="DCEAF1"/>
+                  <a:srgbClr val="203849"/>
                 </a:solidFill>
                 <a:latin typeface="Arial Unicode MS"/>
                 <a:ea typeface="Arial Unicode MS"/>
@@ -5977,7 +5977,7 @@
               <a:buNone/>
               <a:defRPr sz="1425" b="0">
                 <a:solidFill>
-                  <a:srgbClr val="DCEAF1"/>
+                  <a:srgbClr val="203849"/>
                 </a:solidFill>
                 <a:latin typeface="Arial Unicode MS"/>
                 <a:ea typeface="Arial Unicode MS"/>
@@ -5988,7 +5988,7 @@
               <a:buNone/>
               <a:defRPr sz="1425" b="0">
                 <a:solidFill>
-                  <a:srgbClr val="DCEAF1"/>
+                  <a:srgbClr val="203849"/>
                 </a:solidFill>
                 <a:latin typeface="Arial Unicode MS"/>
                 <a:ea typeface="Arial Unicode MS"/>
@@ -5999,7 +5999,7 @@
               <a:buNone/>
               <a:defRPr sz="1425" b="0">
                 <a:solidFill>
-                  <a:srgbClr val="DCEAF1"/>
+                  <a:srgbClr val="203849"/>
                 </a:solidFill>
                 <a:latin typeface="Arial Unicode MS"/>
                 <a:ea typeface="Arial Unicode MS"/>
@@ -6010,7 +6010,7 @@
               <a:buNone/>
               <a:defRPr sz="1425" b="0">
                 <a:solidFill>
-                  <a:srgbClr val="DCEAF1"/>
+                  <a:srgbClr val="203849"/>
                 </a:solidFill>
                 <a:latin typeface="Arial Unicode MS"/>
                 <a:ea typeface="Arial Unicode MS"/>
@@ -6021,7 +6021,7 @@
               <a:buNone/>
               <a:defRPr sz="1425" b="0">
                 <a:solidFill>
-                  <a:srgbClr val="DCEAF1"/>
+                  <a:srgbClr val="203849"/>
                 </a:solidFill>
                 <a:latin typeface="Arial Unicode MS"/>
                 <a:ea typeface="Arial Unicode MS"/>
@@ -6032,7 +6032,7 @@
               <a:buNone/>
               <a:defRPr sz="1425" b="0">
                 <a:solidFill>
-                  <a:srgbClr val="DCEAF1"/>
+                  <a:srgbClr val="203849"/>
                 </a:solidFill>
                 <a:latin typeface="Arial Unicode MS"/>
                 <a:ea typeface="Arial Unicode MS"/>
@@ -6043,7 +6043,7 @@
               <a:buNone/>
               <a:defRPr sz="1425" b="0">
                 <a:solidFill>
-                  <a:srgbClr val="DCEAF1"/>
+                  <a:srgbClr val="203849"/>
                 </a:solidFill>
                 <a:latin typeface="Arial Unicode MS"/>
                 <a:ea typeface="Arial Unicode MS"/>
@@ -6054,7 +6054,7 @@
               <a:buNone/>
               <a:defRPr sz="1425" b="0">
                 <a:solidFill>
-                  <a:srgbClr val="DCEAF1"/>
+                  <a:srgbClr val="203849"/>
                 </a:solidFill>
                 <a:latin typeface="Arial Unicode MS"/>
                 <a:ea typeface="Arial Unicode MS"/>
@@ -6065,7 +6065,7 @@
               <a:buNone/>
               <a:defRPr sz="1425" b="0">
                 <a:solidFill>
-                  <a:srgbClr val="DCEAF1"/>
+                  <a:srgbClr val="203849"/>
                 </a:solidFill>
                 <a:latin typeface="Arial Unicode MS"/>
                 <a:ea typeface="Arial Unicode MS"/>
@@ -6078,7 +6078,7 @@
               <a:buNone/>
               <a:defRPr sz="1425" b="0">
                 <a:solidFill>
-                  <a:srgbClr val="DCEAF1"/>
+                  <a:srgbClr val="203849"/>
                 </a:solidFill>
                 <a:latin typeface="Arial Unicode MS"/>
                 <a:ea typeface="Arial Unicode MS"/>
@@ -6088,7 +6088,7 @@
             <a:r>
               <a:rPr sz="1425" b="0">
                 <a:solidFill>
-                  <a:srgbClr val="DCEAF1"/>
+                  <a:srgbClr val="203849"/>
                 </a:solidFill>
                 <a:latin typeface="Arial Unicode MS"/>
                 <a:ea typeface="Arial Unicode MS"/>
@@ -6122,11 +6122,11 @@
             <a:avLst/>
           </a:prstGeom>
           <a:solidFill xmlns:a="http://schemas.openxmlformats.org/drawingml/2006/main">
-            <a:srgbClr val="334044"/>
+            <a:srgbClr val="FFF5E6"/>
           </a:solidFill>
           <a:ln xmlns:a="http://schemas.openxmlformats.org/drawingml/2006/main" w="14288">
             <a:solidFill>
-              <a:srgbClr val="EEC28B"/>
+              <a:srgbClr val="9A641E"/>
             </a:solidFill>
           </a:ln>
         </p:spPr>
@@ -6166,7 +6166,7 @@
             <a:defPPr algn="ctr">
               <a:defRPr sz="2100" b="1">
                 <a:solidFill>
-                  <a:srgbClr val="FFFFFF"/>
+                  <a:srgbClr val="102C43"/>
                 </a:solidFill>
                 <a:latin typeface="Arial Unicode MS"/>
                 <a:ea typeface="Arial Unicode MS"/>
@@ -6177,7 +6177,7 @@
               <a:buNone/>
               <a:defRPr sz="2100" b="1">
                 <a:solidFill>
-                  <a:srgbClr val="FFFFFF"/>
+                  <a:srgbClr val="102C43"/>
                 </a:solidFill>
                 <a:latin typeface="Arial Unicode MS"/>
                 <a:ea typeface="Arial Unicode MS"/>
@@ -6188,7 +6188,7 @@
               <a:buNone/>
               <a:defRPr sz="2100" b="1">
                 <a:solidFill>
-                  <a:srgbClr val="FFFFFF"/>
+                  <a:srgbClr val="102C43"/>
                 </a:solidFill>
                 <a:latin typeface="Arial Unicode MS"/>
                 <a:ea typeface="Arial Unicode MS"/>
@@ -6199,7 +6199,7 @@
               <a:buNone/>
               <a:defRPr sz="2100" b="1">
                 <a:solidFill>
-                  <a:srgbClr val="FFFFFF"/>
+                  <a:srgbClr val="102C43"/>
                 </a:solidFill>
                 <a:latin typeface="Arial Unicode MS"/>
                 <a:ea typeface="Arial Unicode MS"/>
@@ -6210,7 +6210,7 @@
               <a:buNone/>
               <a:defRPr sz="2100" b="1">
                 <a:solidFill>
-                  <a:srgbClr val="FFFFFF"/>
+                  <a:srgbClr val="102C43"/>
                 </a:solidFill>
                 <a:latin typeface="Arial Unicode MS"/>
                 <a:ea typeface="Arial Unicode MS"/>
@@ -6221,7 +6221,7 @@
               <a:buNone/>
               <a:defRPr sz="2100" b="1">
                 <a:solidFill>
-                  <a:srgbClr val="FFFFFF"/>
+                  <a:srgbClr val="102C43"/>
                 </a:solidFill>
                 <a:latin typeface="Arial Unicode MS"/>
                 <a:ea typeface="Arial Unicode MS"/>
@@ -6232,7 +6232,7 @@
               <a:buNone/>
               <a:defRPr sz="2100" b="1">
                 <a:solidFill>
-                  <a:srgbClr val="FFFFFF"/>
+                  <a:srgbClr val="102C43"/>
                 </a:solidFill>
                 <a:latin typeface="Arial Unicode MS"/>
                 <a:ea typeface="Arial Unicode MS"/>
@@ -6243,7 +6243,7 @@
               <a:buNone/>
               <a:defRPr sz="2100" b="1">
                 <a:solidFill>
-                  <a:srgbClr val="FFFFFF"/>
+                  <a:srgbClr val="102C43"/>
                 </a:solidFill>
                 <a:latin typeface="Arial Unicode MS"/>
                 <a:ea typeface="Arial Unicode MS"/>
@@ -6254,7 +6254,7 @@
               <a:buNone/>
               <a:defRPr sz="2100" b="1">
                 <a:solidFill>
-                  <a:srgbClr val="FFFFFF"/>
+                  <a:srgbClr val="102C43"/>
                 </a:solidFill>
                 <a:latin typeface="Arial Unicode MS"/>
                 <a:ea typeface="Arial Unicode MS"/>
@@ -6265,7 +6265,7 @@
               <a:buNone/>
               <a:defRPr sz="2100" b="1">
                 <a:solidFill>
-                  <a:srgbClr val="FFFFFF"/>
+                  <a:srgbClr val="102C43"/>
                 </a:solidFill>
                 <a:latin typeface="Arial Unicode MS"/>
                 <a:ea typeface="Arial Unicode MS"/>
@@ -6278,7 +6278,7 @@
               <a:buNone/>
               <a:defRPr sz="2100" b="1">
                 <a:solidFill>
-                  <a:srgbClr val="FFFFFF"/>
+                  <a:srgbClr val="102C43"/>
                 </a:solidFill>
                 <a:latin typeface="Arial Unicode MS"/>
                 <a:ea typeface="Arial Unicode MS"/>
@@ -6288,7 +6288,7 @@
             <a:r>
               <a:rPr sz="2100" b="1">
                 <a:solidFill>
-                  <a:srgbClr val="FFFFFF"/>
+                  <a:srgbClr val="102C43"/>
                 </a:solidFill>
                 <a:latin typeface="Arial Unicode MS"/>
                 <a:ea typeface="Arial Unicode MS"/>
@@ -6334,7 +6334,7 @@
             <a:defPPr algn="ctr">
               <a:defRPr sz="1425" b="0">
                 <a:solidFill>
-                  <a:srgbClr val="EEC28B"/>
+                  <a:srgbClr val="9A641E"/>
                 </a:solidFill>
                 <a:latin typeface="Arial Unicode MS"/>
                 <a:ea typeface="Arial Unicode MS"/>
@@ -6345,7 +6345,7 @@
               <a:buNone/>
               <a:defRPr sz="1425" b="0">
                 <a:solidFill>
-                  <a:srgbClr val="EEC28B"/>
+                  <a:srgbClr val="9A641E"/>
                 </a:solidFill>
                 <a:latin typeface="Arial Unicode MS"/>
                 <a:ea typeface="Arial Unicode MS"/>
@@ -6356,7 +6356,7 @@
               <a:buNone/>
               <a:defRPr sz="1425" b="0">
                 <a:solidFill>
-                  <a:srgbClr val="EEC28B"/>
+                  <a:srgbClr val="9A641E"/>
                 </a:solidFill>
                 <a:latin typeface="Arial Unicode MS"/>
                 <a:ea typeface="Arial Unicode MS"/>
@@ -6367,7 +6367,7 @@
               <a:buNone/>
               <a:defRPr sz="1425" b="0">
                 <a:solidFill>
-                  <a:srgbClr val="EEC28B"/>
+                  <a:srgbClr val="9A641E"/>
                 </a:solidFill>
                 <a:latin typeface="Arial Unicode MS"/>
                 <a:ea typeface="Arial Unicode MS"/>
@@ -6378,7 +6378,7 @@
               <a:buNone/>
               <a:defRPr sz="1425" b="0">
                 <a:solidFill>
-                  <a:srgbClr val="EEC28B"/>
+                  <a:srgbClr val="9A641E"/>
                 </a:solidFill>
                 <a:latin typeface="Arial Unicode MS"/>
                 <a:ea typeface="Arial Unicode MS"/>
@@ -6389,7 +6389,7 @@
               <a:buNone/>
               <a:defRPr sz="1425" b="0">
                 <a:solidFill>
-                  <a:srgbClr val="EEC28B"/>
+                  <a:srgbClr val="9A641E"/>
                 </a:solidFill>
                 <a:latin typeface="Arial Unicode MS"/>
                 <a:ea typeface="Arial Unicode MS"/>
@@ -6400,7 +6400,7 @@
               <a:buNone/>
               <a:defRPr sz="1425" b="0">
                 <a:solidFill>
-                  <a:srgbClr val="EEC28B"/>
+                  <a:srgbClr val="9A641E"/>
                 </a:solidFill>
                 <a:latin typeface="Arial Unicode MS"/>
                 <a:ea typeface="Arial Unicode MS"/>
@@ -6411,7 +6411,7 @@
               <a:buNone/>
               <a:defRPr sz="1425" b="0">
                 <a:solidFill>
-                  <a:srgbClr val="EEC28B"/>
+                  <a:srgbClr val="9A641E"/>
                 </a:solidFill>
                 <a:latin typeface="Arial Unicode MS"/>
                 <a:ea typeface="Arial Unicode MS"/>
@@ -6422,7 +6422,7 @@
               <a:buNone/>
               <a:defRPr sz="1425" b="0">
                 <a:solidFill>
-                  <a:srgbClr val="EEC28B"/>
+                  <a:srgbClr val="9A641E"/>
                 </a:solidFill>
                 <a:latin typeface="Arial Unicode MS"/>
                 <a:ea typeface="Arial Unicode MS"/>
@@ -6433,7 +6433,7 @@
               <a:buNone/>
               <a:defRPr sz="1425" b="0">
                 <a:solidFill>
-                  <a:srgbClr val="EEC28B"/>
+                  <a:srgbClr val="9A641E"/>
                 </a:solidFill>
                 <a:latin typeface="Arial Unicode MS"/>
                 <a:ea typeface="Arial Unicode MS"/>
@@ -6446,7 +6446,7 @@
               <a:buNone/>
               <a:defRPr sz="1425" b="0">
                 <a:solidFill>
-                  <a:srgbClr val="EEC28B"/>
+                  <a:srgbClr val="9A641E"/>
                 </a:solidFill>
                 <a:latin typeface="Arial Unicode MS"/>
                 <a:ea typeface="Arial Unicode MS"/>
@@ -6456,7 +6456,7 @@
             <a:r>
               <a:rPr sz="1425" b="0">
                 <a:solidFill>
-                  <a:srgbClr val="EEC28B"/>
+                  <a:srgbClr val="9A641E"/>
                 </a:solidFill>
                 <a:latin typeface="Arial Unicode MS"/>
                 <a:ea typeface="Arial Unicode MS"/>
@@ -6490,11 +6490,11 @@
             <a:avLst/>
           </a:prstGeom>
           <a:solidFill xmlns:a="http://schemas.openxmlformats.org/drawingml/2006/main">
-            <a:srgbClr val="334044"/>
+            <a:srgbClr val="FFF5E6"/>
           </a:solidFill>
           <a:ln xmlns:a="http://schemas.openxmlformats.org/drawingml/2006/main" w="14288">
             <a:solidFill>
-              <a:srgbClr val="EEC28B"/>
+              <a:srgbClr val="9A641E"/>
             </a:solidFill>
           </a:ln>
         </p:spPr>
@@ -6534,7 +6534,7 @@
             <a:defPPr algn="ctr">
               <a:defRPr sz="2100" b="1">
                 <a:solidFill>
-                  <a:srgbClr val="FFFFFF"/>
+                  <a:srgbClr val="102C43"/>
                 </a:solidFill>
                 <a:latin typeface="Arial Unicode MS"/>
                 <a:ea typeface="Arial Unicode MS"/>
@@ -6545,7 +6545,7 @@
               <a:buNone/>
               <a:defRPr sz="2100" b="1">
                 <a:solidFill>
-                  <a:srgbClr val="FFFFFF"/>
+                  <a:srgbClr val="102C43"/>
                 </a:solidFill>
                 <a:latin typeface="Arial Unicode MS"/>
                 <a:ea typeface="Arial Unicode MS"/>
@@ -6556,7 +6556,7 @@
               <a:buNone/>
               <a:defRPr sz="2100" b="1">
                 <a:solidFill>
-                  <a:srgbClr val="FFFFFF"/>
+                  <a:srgbClr val="102C43"/>
                 </a:solidFill>
                 <a:latin typeface="Arial Unicode MS"/>
                 <a:ea typeface="Arial Unicode MS"/>
@@ -6567,7 +6567,7 @@
               <a:buNone/>
               <a:defRPr sz="2100" b="1">
                 <a:solidFill>
-                  <a:srgbClr val="FFFFFF"/>
+                  <a:srgbClr val="102C43"/>
                 </a:solidFill>
                 <a:latin typeface="Arial Unicode MS"/>
                 <a:ea typeface="Arial Unicode MS"/>
@@ -6578,7 +6578,7 @@
               <a:buNone/>
               <a:defRPr sz="2100" b="1">
                 <a:solidFill>
-                  <a:srgbClr val="FFFFFF"/>
+                  <a:srgbClr val="102C43"/>
                 </a:solidFill>
                 <a:latin typeface="Arial Unicode MS"/>
                 <a:ea typeface="Arial Unicode MS"/>
@@ -6589,7 +6589,7 @@
               <a:buNone/>
               <a:defRPr sz="2100" b="1">
                 <a:solidFill>
-                  <a:srgbClr val="FFFFFF"/>
+                  <a:srgbClr val="102C43"/>
                 </a:solidFill>
                 <a:latin typeface="Arial Unicode MS"/>
                 <a:ea typeface="Arial Unicode MS"/>
@@ -6600,7 +6600,7 @@
               <a:buNone/>
               <a:defRPr sz="2100" b="1">
                 <a:solidFill>
-                  <a:srgbClr val="FFFFFF"/>
+                  <a:srgbClr val="102C43"/>
                 </a:solidFill>
                 <a:latin typeface="Arial Unicode MS"/>
                 <a:ea typeface="Arial Unicode MS"/>
@@ -6611,7 +6611,7 @@
               <a:buNone/>
               <a:defRPr sz="2100" b="1">
                 <a:solidFill>
-                  <a:srgbClr val="FFFFFF"/>
+                  <a:srgbClr val="102C43"/>
                 </a:solidFill>
                 <a:latin typeface="Arial Unicode MS"/>
                 <a:ea typeface="Arial Unicode MS"/>
@@ -6622,7 +6622,7 @@
               <a:buNone/>
               <a:defRPr sz="2100" b="1">
                 <a:solidFill>
-                  <a:srgbClr val="FFFFFF"/>
+                  <a:srgbClr val="102C43"/>
                 </a:solidFill>
                 <a:latin typeface="Arial Unicode MS"/>
                 <a:ea typeface="Arial Unicode MS"/>
@@ -6633,7 +6633,7 @@
               <a:buNone/>
               <a:defRPr sz="2100" b="1">
                 <a:solidFill>
-                  <a:srgbClr val="FFFFFF"/>
+                  <a:srgbClr val="102C43"/>
                 </a:solidFill>
                 <a:latin typeface="Arial Unicode MS"/>
                 <a:ea typeface="Arial Unicode MS"/>
@@ -6646,7 +6646,7 @@
               <a:buNone/>
               <a:defRPr sz="2100" b="1">
                 <a:solidFill>
-                  <a:srgbClr val="FFFFFF"/>
+                  <a:srgbClr val="102C43"/>
                 </a:solidFill>
                 <a:latin typeface="Arial Unicode MS"/>
                 <a:ea typeface="Arial Unicode MS"/>
@@ -6656,7 +6656,7 @@
             <a:r>
               <a:rPr sz="2100" b="1">
                 <a:solidFill>
-                  <a:srgbClr val="FFFFFF"/>
+                  <a:srgbClr val="102C43"/>
                 </a:solidFill>
                 <a:latin typeface="Arial Unicode MS"/>
                 <a:ea typeface="Arial Unicode MS"/>
@@ -6702,7 +6702,7 @@
             <a:defPPr algn="ctr">
               <a:defRPr sz="1425" b="0">
                 <a:solidFill>
-                  <a:srgbClr val="EEC28B"/>
+                  <a:srgbClr val="9A641E"/>
                 </a:solidFill>
                 <a:latin typeface="Arial Unicode MS"/>
                 <a:ea typeface="Arial Unicode MS"/>
@@ -6713,7 +6713,7 @@
               <a:buNone/>
               <a:defRPr sz="1425" b="0">
                 <a:solidFill>
-                  <a:srgbClr val="EEC28B"/>
+                  <a:srgbClr val="9A641E"/>
                 </a:solidFill>
                 <a:latin typeface="Arial Unicode MS"/>
                 <a:ea typeface="Arial Unicode MS"/>
@@ -6724,7 +6724,7 @@
               <a:buNone/>
               <a:defRPr sz="1425" b="0">
                 <a:solidFill>
-                  <a:srgbClr val="EEC28B"/>
+                  <a:srgbClr val="9A641E"/>
                 </a:solidFill>
                 <a:latin typeface="Arial Unicode MS"/>
                 <a:ea typeface="Arial Unicode MS"/>
@@ -6735,7 +6735,7 @@
               <a:buNone/>
               <a:defRPr sz="1425" b="0">
                 <a:solidFill>
-                  <a:srgbClr val="EEC28B"/>
+                  <a:srgbClr val="9A641E"/>
                 </a:solidFill>
                 <a:latin typeface="Arial Unicode MS"/>
                 <a:ea typeface="Arial Unicode MS"/>
@@ -6746,7 +6746,7 @@
               <a:buNone/>
               <a:defRPr sz="1425" b="0">
                 <a:solidFill>
-                  <a:srgbClr val="EEC28B"/>
+                  <a:srgbClr val="9A641E"/>
                 </a:solidFill>
                 <a:latin typeface="Arial Unicode MS"/>
                 <a:ea typeface="Arial Unicode MS"/>
@@ -6757,7 +6757,7 @@
               <a:buNone/>
               <a:defRPr sz="1425" b="0">
                 <a:solidFill>
-                  <a:srgbClr val="EEC28B"/>
+                  <a:srgbClr val="9A641E"/>
                 </a:solidFill>
                 <a:latin typeface="Arial Unicode MS"/>
                 <a:ea typeface="Arial Unicode MS"/>
@@ -6768,7 +6768,7 @@
               <a:buNone/>
               <a:defRPr sz="1425" b="0">
                 <a:solidFill>
-                  <a:srgbClr val="EEC28B"/>
+                  <a:srgbClr val="9A641E"/>
                 </a:solidFill>
                 <a:latin typeface="Arial Unicode MS"/>
                 <a:ea typeface="Arial Unicode MS"/>
@@ -6779,7 +6779,7 @@
               <a:buNone/>
               <a:defRPr sz="1425" b="0">
                 <a:solidFill>
-                  <a:srgbClr val="EEC28B"/>
+                  <a:srgbClr val="9A641E"/>
                 </a:solidFill>
                 <a:latin typeface="Arial Unicode MS"/>
                 <a:ea typeface="Arial Unicode MS"/>
@@ -6790,7 +6790,7 @@
               <a:buNone/>
               <a:defRPr sz="1425" b="0">
                 <a:solidFill>
-                  <a:srgbClr val="EEC28B"/>
+                  <a:srgbClr val="9A641E"/>
                 </a:solidFill>
                 <a:latin typeface="Arial Unicode MS"/>
                 <a:ea typeface="Arial Unicode MS"/>
@@ -6801,7 +6801,7 @@
               <a:buNone/>
               <a:defRPr sz="1425" b="0">
                 <a:solidFill>
-                  <a:srgbClr val="EEC28B"/>
+                  <a:srgbClr val="9A641E"/>
                 </a:solidFill>
                 <a:latin typeface="Arial Unicode MS"/>
                 <a:ea typeface="Arial Unicode MS"/>
@@ -6814,7 +6814,7 @@
               <a:buNone/>
               <a:defRPr sz="1425" b="0">
                 <a:solidFill>
-                  <a:srgbClr val="EEC28B"/>
+                  <a:srgbClr val="9A641E"/>
                 </a:solidFill>
                 <a:latin typeface="Arial Unicode MS"/>
                 <a:ea typeface="Arial Unicode MS"/>
@@ -6824,7 +6824,7 @@
             <a:r>
               <a:rPr sz="1425" b="0">
                 <a:solidFill>
-                  <a:srgbClr val="EEC28B"/>
+                  <a:srgbClr val="9A641E"/>
                 </a:solidFill>
                 <a:latin typeface="Arial Unicode MS"/>
                 <a:ea typeface="Arial Unicode MS"/>
@@ -6858,11 +6858,11 @@
             <a:avLst/>
           </a:prstGeom>
           <a:solidFill xmlns:a="http://schemas.openxmlformats.org/drawingml/2006/main">
-            <a:srgbClr val="334044"/>
+            <a:srgbClr val="FFF5E6"/>
           </a:solidFill>
           <a:ln xmlns:a="http://schemas.openxmlformats.org/drawingml/2006/main" w="14288">
             <a:solidFill>
-              <a:srgbClr val="EEC28B"/>
+              <a:srgbClr val="9A641E"/>
             </a:solidFill>
           </a:ln>
         </p:spPr>
@@ -6902,7 +6902,7 @@
             <a:defPPr algn="ctr">
               <a:defRPr sz="2100" b="1">
                 <a:solidFill>
-                  <a:srgbClr val="FFFFFF"/>
+                  <a:srgbClr val="102C43"/>
                 </a:solidFill>
                 <a:latin typeface="Arial Unicode MS"/>
                 <a:ea typeface="Arial Unicode MS"/>
@@ -6913,7 +6913,7 @@
               <a:buNone/>
               <a:defRPr sz="2100" b="1">
                 <a:solidFill>
-                  <a:srgbClr val="FFFFFF"/>
+                  <a:srgbClr val="102C43"/>
                 </a:solidFill>
                 <a:latin typeface="Arial Unicode MS"/>
                 <a:ea typeface="Arial Unicode MS"/>
@@ -6924,7 +6924,7 @@
               <a:buNone/>
               <a:defRPr sz="2100" b="1">
                 <a:solidFill>
-                  <a:srgbClr val="FFFFFF"/>
+                  <a:srgbClr val="102C43"/>
                 </a:solidFill>
                 <a:latin typeface="Arial Unicode MS"/>
                 <a:ea typeface="Arial Unicode MS"/>
@@ -6935,7 +6935,7 @@
               <a:buNone/>
               <a:defRPr sz="2100" b="1">
                 <a:solidFill>
-                  <a:srgbClr val="FFFFFF"/>
+                  <a:srgbClr val="102C43"/>
                 </a:solidFill>
                 <a:latin typeface="Arial Unicode MS"/>
                 <a:ea typeface="Arial Unicode MS"/>
@@ -6946,7 +6946,7 @@
               <a:buNone/>
               <a:defRPr sz="2100" b="1">
                 <a:solidFill>
-                  <a:srgbClr val="FFFFFF"/>
+                  <a:srgbClr val="102C43"/>
                 </a:solidFill>
                 <a:latin typeface="Arial Unicode MS"/>
                 <a:ea typeface="Arial Unicode MS"/>
@@ -6957,7 +6957,7 @@
               <a:buNone/>
               <a:defRPr sz="2100" b="1">
                 <a:solidFill>
-                  <a:srgbClr val="FFFFFF"/>
+                  <a:srgbClr val="102C43"/>
                 </a:solidFill>
                 <a:latin typeface="Arial Unicode MS"/>
                 <a:ea typeface="Arial Unicode MS"/>
@@ -6968,7 +6968,7 @@
               <a:buNone/>
               <a:defRPr sz="2100" b="1">
                 <a:solidFill>
-                  <a:srgbClr val="FFFFFF"/>
+                  <a:srgbClr val="102C43"/>
                 </a:solidFill>
                 <a:latin typeface="Arial Unicode MS"/>
                 <a:ea typeface="Arial Unicode MS"/>
@@ -6979,7 +6979,7 @@
               <a:buNone/>
               <a:defRPr sz="2100" b="1">
                 <a:solidFill>
-                  <a:srgbClr val="FFFFFF"/>
+                  <a:srgbClr val="102C43"/>
                 </a:solidFill>
                 <a:latin typeface="Arial Unicode MS"/>
                 <a:ea typeface="Arial Unicode MS"/>
@@ -6990,7 +6990,7 @@
               <a:buNone/>
               <a:defRPr sz="2100" b="1">
                 <a:solidFill>
-                  <a:srgbClr val="FFFFFF"/>
+                  <a:srgbClr val="102C43"/>
                 </a:solidFill>
                 <a:latin typeface="Arial Unicode MS"/>
                 <a:ea typeface="Arial Unicode MS"/>
@@ -7001,7 +7001,7 @@
               <a:buNone/>
               <a:defRPr sz="2100" b="1">
                 <a:solidFill>
-                  <a:srgbClr val="FFFFFF"/>
+                  <a:srgbClr val="102C43"/>
                 </a:solidFill>
                 <a:latin typeface="Arial Unicode MS"/>
                 <a:ea typeface="Arial Unicode MS"/>
@@ -7014,7 +7014,7 @@
               <a:buNone/>
               <a:defRPr sz="2100" b="1">
                 <a:solidFill>
-                  <a:srgbClr val="FFFFFF"/>
+                  <a:srgbClr val="102C43"/>
                 </a:solidFill>
                 <a:latin typeface="Arial Unicode MS"/>
                 <a:ea typeface="Arial Unicode MS"/>
@@ -7024,7 +7024,7 @@
             <a:r>
               <a:rPr sz="2100" b="1">
                 <a:solidFill>
-                  <a:srgbClr val="FFFFFF"/>
+                  <a:srgbClr val="102C43"/>
                 </a:solidFill>
                 <a:latin typeface="Arial Unicode MS"/>
                 <a:ea typeface="Arial Unicode MS"/>
@@ -7070,7 +7070,7 @@
             <a:defPPr algn="ctr">
               <a:defRPr sz="1425" b="0">
                 <a:solidFill>
-                  <a:srgbClr val="EEC28B"/>
+                  <a:srgbClr val="9A641E"/>
                 </a:solidFill>
                 <a:latin typeface="Arial Unicode MS"/>
                 <a:ea typeface="Arial Unicode MS"/>
@@ -7081,7 +7081,7 @@
               <a:buNone/>
               <a:defRPr sz="1425" b="0">
                 <a:solidFill>
-                  <a:srgbClr val="EEC28B"/>
+                  <a:srgbClr val="9A641E"/>
                 </a:solidFill>
                 <a:latin typeface="Arial Unicode MS"/>
                 <a:ea typeface="Arial Unicode MS"/>
@@ -7092,7 +7092,7 @@
               <a:buNone/>
               <a:defRPr sz="1425" b="0">
                 <a:solidFill>
-                  <a:srgbClr val="EEC28B"/>
+                  <a:srgbClr val="9A641E"/>
                 </a:solidFill>
                 <a:latin typeface="Arial Unicode MS"/>
                 <a:ea typeface="Arial Unicode MS"/>
@@ -7103,7 +7103,7 @@
               <a:buNone/>
               <a:defRPr sz="1425" b="0">
                 <a:solidFill>
-                  <a:srgbClr val="EEC28B"/>
+                  <a:srgbClr val="9A641E"/>
                 </a:solidFill>
                 <a:latin typeface="Arial Unicode MS"/>
                 <a:ea typeface="Arial Unicode MS"/>
@@ -7114,7 +7114,7 @@
               <a:buNone/>
               <a:defRPr sz="1425" b="0">
                 <a:solidFill>
-                  <a:srgbClr val="EEC28B"/>
+                  <a:srgbClr val="9A641E"/>
                 </a:solidFill>
                 <a:latin typeface="Arial Unicode MS"/>
                 <a:ea typeface="Arial Unicode MS"/>
@@ -7125,7 +7125,7 @@
               <a:buNone/>
               <a:defRPr sz="1425" b="0">
                 <a:solidFill>
-                  <a:srgbClr val="EEC28B"/>
+                  <a:srgbClr val="9A641E"/>
                 </a:solidFill>
                 <a:latin typeface="Arial Unicode MS"/>
                 <a:ea typeface="Arial Unicode MS"/>
@@ -7136,7 +7136,7 @@
               <a:buNone/>
               <a:defRPr sz="1425" b="0">
                 <a:solidFill>
-                  <a:srgbClr val="EEC28B"/>
+                  <a:srgbClr val="9A641E"/>
                 </a:solidFill>
                 <a:latin typeface="Arial Unicode MS"/>
                 <a:ea typeface="Arial Unicode MS"/>
@@ -7147,7 +7147,7 @@
               <a:buNone/>
               <a:defRPr sz="1425" b="0">
                 <a:solidFill>
-                  <a:srgbClr val="EEC28B"/>
+                  <a:srgbClr val="9A641E"/>
                 </a:solidFill>
                 <a:latin typeface="Arial Unicode MS"/>
                 <a:ea typeface="Arial Unicode MS"/>
@@ -7158,7 +7158,7 @@
               <a:buNone/>
               <a:defRPr sz="1425" b="0">
                 <a:solidFill>
-                  <a:srgbClr val="EEC28B"/>
+                  <a:srgbClr val="9A641E"/>
                 </a:solidFill>
                 <a:latin typeface="Arial Unicode MS"/>
                 <a:ea typeface="Arial Unicode MS"/>
@@ -7169,7 +7169,7 @@
               <a:buNone/>
               <a:defRPr sz="1425" b="0">
                 <a:solidFill>
-                  <a:srgbClr val="EEC28B"/>
+                  <a:srgbClr val="9A641E"/>
                 </a:solidFill>
                 <a:latin typeface="Arial Unicode MS"/>
                 <a:ea typeface="Arial Unicode MS"/>
@@ -7182,7 +7182,7 @@
               <a:buNone/>
               <a:defRPr sz="1425" b="0">
                 <a:solidFill>
-                  <a:srgbClr val="EEC28B"/>
+                  <a:srgbClr val="9A641E"/>
                 </a:solidFill>
                 <a:latin typeface="Arial Unicode MS"/>
                 <a:ea typeface="Arial Unicode MS"/>
@@ -7192,7 +7192,7 @@
             <a:r>
               <a:rPr sz="1425" b="0">
                 <a:solidFill>
-                  <a:srgbClr val="EEC28B"/>
+                  <a:srgbClr val="9A641E"/>
                 </a:solidFill>
                 <a:latin typeface="Arial Unicode MS"/>
                 <a:ea typeface="Arial Unicode MS"/>
@@ -7226,11 +7226,11 @@
             <a:avLst/>
           </a:prstGeom>
           <a:solidFill xmlns:a="http://schemas.openxmlformats.org/drawingml/2006/main">
-            <a:srgbClr val="334044"/>
+            <a:srgbClr val="FFF5E6"/>
           </a:solidFill>
           <a:ln xmlns:a="http://schemas.openxmlformats.org/drawingml/2006/main" w="14288">
             <a:solidFill>
-              <a:srgbClr val="EEC28B"/>
+              <a:srgbClr val="9A641E"/>
             </a:solidFill>
           </a:ln>
         </p:spPr>
@@ -7270,7 +7270,7 @@
             <a:defPPr algn="ctr">
               <a:defRPr sz="2100" b="1">
                 <a:solidFill>
-                  <a:srgbClr val="FFFFFF"/>
+                  <a:srgbClr val="102C43"/>
                 </a:solidFill>
                 <a:latin typeface="Arial Unicode MS"/>
                 <a:ea typeface="Arial Unicode MS"/>
@@ -7281,7 +7281,7 @@
               <a:buNone/>
               <a:defRPr sz="2100" b="1">
                 <a:solidFill>
-                  <a:srgbClr val="FFFFFF"/>
+                  <a:srgbClr val="102C43"/>
                 </a:solidFill>
                 <a:latin typeface="Arial Unicode MS"/>
                 <a:ea typeface="Arial Unicode MS"/>
@@ -7292,7 +7292,7 @@
               <a:buNone/>
               <a:defRPr sz="2100" b="1">
                 <a:solidFill>
-                  <a:srgbClr val="FFFFFF"/>
+                  <a:srgbClr val="102C43"/>
                 </a:solidFill>
                 <a:latin typeface="Arial Unicode MS"/>
                 <a:ea typeface="Arial Unicode MS"/>
@@ -7303,7 +7303,7 @@
               <a:buNone/>
               <a:defRPr sz="2100" b="1">
                 <a:solidFill>
-                  <a:srgbClr val="FFFFFF"/>
+                  <a:srgbClr val="102C43"/>
                 </a:solidFill>
                 <a:latin typeface="Arial Unicode MS"/>
                 <a:ea typeface="Arial Unicode MS"/>
@@ -7314,7 +7314,7 @@
               <a:buNone/>
               <a:defRPr sz="2100" b="1">
                 <a:solidFill>
-                  <a:srgbClr val="FFFFFF"/>
+                  <a:srgbClr val="102C43"/>
                 </a:solidFill>
                 <a:latin typeface="Arial Unicode MS"/>
                 <a:ea typeface="Arial Unicode MS"/>
@@ -7325,7 +7325,7 @@
               <a:buNone/>
               <a:defRPr sz="2100" b="1">
                 <a:solidFill>
-                  <a:srgbClr val="FFFFFF"/>
+                  <a:srgbClr val="102C43"/>
                 </a:solidFill>
                 <a:latin typeface="Arial Unicode MS"/>
                 <a:ea typeface="Arial Unicode MS"/>
@@ -7336,7 +7336,7 @@
               <a:buNone/>
               <a:defRPr sz="2100" b="1">
                 <a:solidFill>
-                  <a:srgbClr val="FFFFFF"/>
+                  <a:srgbClr val="102C43"/>
                 </a:solidFill>
                 <a:latin typeface="Arial Unicode MS"/>
                 <a:ea typeface="Arial Unicode MS"/>
@@ -7347,7 +7347,7 @@
               <a:buNone/>
               <a:defRPr sz="2100" b="1">
                 <a:solidFill>
-                  <a:srgbClr val="FFFFFF"/>
+                  <a:srgbClr val="102C43"/>
                 </a:solidFill>
                 <a:latin typeface="Arial Unicode MS"/>
                 <a:ea typeface="Arial Unicode MS"/>
@@ -7358,7 +7358,7 @@
               <a:buNone/>
               <a:defRPr sz="2100" b="1">
                 <a:solidFill>
-                  <a:srgbClr val="FFFFFF"/>
+                  <a:srgbClr val="102C43"/>
                 </a:solidFill>
                 <a:latin typeface="Arial Unicode MS"/>
                 <a:ea typeface="Arial Unicode MS"/>
@@ -7369,7 +7369,7 @@
               <a:buNone/>
               <a:defRPr sz="2100" b="1">
                 <a:solidFill>
-                  <a:srgbClr val="FFFFFF"/>
+                  <a:srgbClr val="102C43"/>
                 </a:solidFill>
                 <a:latin typeface="Arial Unicode MS"/>
                 <a:ea typeface="Arial Unicode MS"/>
@@ -7382,7 +7382,7 @@
               <a:buNone/>
               <a:defRPr sz="2100" b="1">
                 <a:solidFill>
-                  <a:srgbClr val="FFFFFF"/>
+                  <a:srgbClr val="102C43"/>
                 </a:solidFill>
                 <a:latin typeface="Arial Unicode MS"/>
                 <a:ea typeface="Arial Unicode MS"/>
@@ -7392,7 +7392,7 @@
             <a:r>
               <a:rPr sz="2100" b="1">
                 <a:solidFill>
-                  <a:srgbClr val="FFFFFF"/>
+                  <a:srgbClr val="102C43"/>
                 </a:solidFill>
                 <a:latin typeface="Arial Unicode MS"/>
                 <a:ea typeface="Arial Unicode MS"/>
@@ -7438,7 +7438,7 @@
             <a:defPPr algn="ctr">
               <a:defRPr sz="1425" b="0">
                 <a:solidFill>
-                  <a:srgbClr val="EEC28B"/>
+                  <a:srgbClr val="9A641E"/>
                 </a:solidFill>
                 <a:latin typeface="Arial Unicode MS"/>
                 <a:ea typeface="Arial Unicode MS"/>
@@ -7449,7 +7449,7 @@
               <a:buNone/>
               <a:defRPr sz="1425" b="0">
                 <a:solidFill>
-                  <a:srgbClr val="EEC28B"/>
+                  <a:srgbClr val="9A641E"/>
                 </a:solidFill>
                 <a:latin typeface="Arial Unicode MS"/>
                 <a:ea typeface="Arial Unicode MS"/>
@@ -7460,7 +7460,7 @@
               <a:buNone/>
               <a:defRPr sz="1425" b="0">
                 <a:solidFill>
-                  <a:srgbClr val="EEC28B"/>
+                  <a:srgbClr val="9A641E"/>
                 </a:solidFill>
                 <a:latin typeface="Arial Unicode MS"/>
                 <a:ea typeface="Arial Unicode MS"/>
@@ -7471,7 +7471,7 @@
               <a:buNone/>
               <a:defRPr sz="1425" b="0">
                 <a:solidFill>
-                  <a:srgbClr val="EEC28B"/>
+                  <a:srgbClr val="9A641E"/>
                 </a:solidFill>
                 <a:latin typeface="Arial Unicode MS"/>
                 <a:ea typeface="Arial Unicode MS"/>
@@ -7482,7 +7482,7 @@
               <a:buNone/>
               <a:defRPr sz="1425" b="0">
                 <a:solidFill>
-                  <a:srgbClr val="EEC28B"/>
+                  <a:srgbClr val="9A641E"/>
                 </a:solidFill>
                 <a:latin typeface="Arial Unicode MS"/>
                 <a:ea typeface="Arial Unicode MS"/>
@@ -7493,7 +7493,7 @@
               <a:buNone/>
               <a:defRPr sz="1425" b="0">
                 <a:solidFill>
-                  <a:srgbClr val="EEC28B"/>
+                  <a:srgbClr val="9A641E"/>
                 </a:solidFill>
                 <a:latin typeface="Arial Unicode MS"/>
                 <a:ea typeface="Arial Unicode MS"/>
@@ -7504,7 +7504,7 @@
               <a:buNone/>
               <a:defRPr sz="1425" b="0">
                 <a:solidFill>
-                  <a:srgbClr val="EEC28B"/>
+                  <a:srgbClr val="9A641E"/>
                 </a:solidFill>
                 <a:latin typeface="Arial Unicode MS"/>
                 <a:ea typeface="Arial Unicode MS"/>
@@ -7515,7 +7515,7 @@
               <a:buNone/>
               <a:defRPr sz="1425" b="0">
                 <a:solidFill>
-                  <a:srgbClr val="EEC28B"/>
+                  <a:srgbClr val="9A641E"/>
                 </a:solidFill>
                 <a:latin typeface="Arial Unicode MS"/>
                 <a:ea typeface="Arial Unicode MS"/>
@@ -7526,7 +7526,7 @@
               <a:buNone/>
               <a:defRPr sz="1425" b="0">
                 <a:solidFill>
-                  <a:srgbClr val="EEC28B"/>
+                  <a:srgbClr val="9A641E"/>
                 </a:solidFill>
                 <a:latin typeface="Arial Unicode MS"/>
                 <a:ea typeface="Arial Unicode MS"/>
@@ -7537,7 +7537,7 @@
               <a:buNone/>
               <a:defRPr sz="1425" b="0">
                 <a:solidFill>
-                  <a:srgbClr val="EEC28B"/>
+                  <a:srgbClr val="9A641E"/>
                 </a:solidFill>
                 <a:latin typeface="Arial Unicode MS"/>
                 <a:ea typeface="Arial Unicode MS"/>
@@ -7550,7 +7550,7 @@
               <a:buNone/>
               <a:defRPr sz="1425" b="0">
                 <a:solidFill>
-                  <a:srgbClr val="EEC28B"/>
+                  <a:srgbClr val="9A641E"/>
                 </a:solidFill>
                 <a:latin typeface="Arial Unicode MS"/>
                 <a:ea typeface="Arial Unicode MS"/>
@@ -7560,7 +7560,7 @@
             <a:r>
               <a:rPr sz="1425" b="0">
                 <a:solidFill>
-                  <a:srgbClr val="EEC28B"/>
+                  <a:srgbClr val="9A641E"/>
                 </a:solidFill>
                 <a:latin typeface="Arial Unicode MS"/>
                 <a:ea typeface="Arial Unicode MS"/>
@@ -7594,11 +7594,11 @@
             <a:avLst/>
           </a:prstGeom>
           <a:solidFill xmlns:a="http://schemas.openxmlformats.org/drawingml/2006/main">
-            <a:srgbClr val="183A53"/>
+            <a:srgbClr val="EAF5F4"/>
           </a:solidFill>
           <a:ln xmlns:a="http://schemas.openxmlformats.org/drawingml/2006/main" w="14288">
             <a:solidFill>
-              <a:srgbClr val="587386"/>
+              <a:srgbClr val="9BADB8"/>
             </a:solidFill>
           </a:ln>
         </p:spPr>
@@ -7638,7 +7638,7 @@
             <a:defPPr algn="ctr">
               <a:defRPr sz="2100" b="1">
                 <a:solidFill>
-                  <a:srgbClr val="FFFFFF"/>
+                  <a:srgbClr val="102C43"/>
                 </a:solidFill>
                 <a:latin typeface="Arial Unicode MS"/>
                 <a:ea typeface="Arial Unicode MS"/>
@@ -7649,7 +7649,7 @@
               <a:buNone/>
               <a:defRPr sz="2100" b="1">
                 <a:solidFill>
-                  <a:srgbClr val="FFFFFF"/>
+                  <a:srgbClr val="102C43"/>
                 </a:solidFill>
                 <a:latin typeface="Arial Unicode MS"/>
                 <a:ea typeface="Arial Unicode MS"/>
@@ -7660,7 +7660,7 @@
               <a:buNone/>
               <a:defRPr sz="2100" b="1">
                 <a:solidFill>
-                  <a:srgbClr val="FFFFFF"/>
+                  <a:srgbClr val="102C43"/>
                 </a:solidFill>
                 <a:latin typeface="Arial Unicode MS"/>
                 <a:ea typeface="Arial Unicode MS"/>
@@ -7671,7 +7671,7 @@
               <a:buNone/>
               <a:defRPr sz="2100" b="1">
                 <a:solidFill>
-                  <a:srgbClr val="FFFFFF"/>
+                  <a:srgbClr val="102C43"/>
                 </a:solidFill>
                 <a:latin typeface="Arial Unicode MS"/>
                 <a:ea typeface="Arial Unicode MS"/>
@@ -7682,7 +7682,7 @@
               <a:buNone/>
               <a:defRPr sz="2100" b="1">
                 <a:solidFill>
-                  <a:srgbClr val="FFFFFF"/>
+                  <a:srgbClr val="102C43"/>
                 </a:solidFill>
                 <a:latin typeface="Arial Unicode MS"/>
                 <a:ea typeface="Arial Unicode MS"/>
@@ -7693,7 +7693,7 @@
               <a:buNone/>
               <a:defRPr sz="2100" b="1">
                 <a:solidFill>
-                  <a:srgbClr val="FFFFFF"/>
+                  <a:srgbClr val="102C43"/>
                 </a:solidFill>
                 <a:latin typeface="Arial Unicode MS"/>
                 <a:ea typeface="Arial Unicode MS"/>
@@ -7704,7 +7704,7 @@
               <a:buNone/>
               <a:defRPr sz="2100" b="1">
                 <a:solidFill>
-                  <a:srgbClr val="FFFFFF"/>
+                  <a:srgbClr val="102C43"/>
                 </a:solidFill>
                 <a:latin typeface="Arial Unicode MS"/>
                 <a:ea typeface="Arial Unicode MS"/>
@@ -7715,7 +7715,7 @@
               <a:buNone/>
               <a:defRPr sz="2100" b="1">
                 <a:solidFill>
-                  <a:srgbClr val="FFFFFF"/>
+                  <a:srgbClr val="102C43"/>
                 </a:solidFill>
                 <a:latin typeface="Arial Unicode MS"/>
                 <a:ea typeface="Arial Unicode MS"/>
@@ -7726,7 +7726,7 @@
               <a:buNone/>
               <a:defRPr sz="2100" b="1">
                 <a:solidFill>
-                  <a:srgbClr val="FFFFFF"/>
+                  <a:srgbClr val="102C43"/>
                 </a:solidFill>
                 <a:latin typeface="Arial Unicode MS"/>
                 <a:ea typeface="Arial Unicode MS"/>
@@ -7737,7 +7737,7 @@
               <a:buNone/>
               <a:defRPr sz="2100" b="1">
                 <a:solidFill>
-                  <a:srgbClr val="FFFFFF"/>
+                  <a:srgbClr val="102C43"/>
                 </a:solidFill>
                 <a:latin typeface="Arial Unicode MS"/>
                 <a:ea typeface="Arial Unicode MS"/>
@@ -7750,7 +7750,7 @@
               <a:buNone/>
               <a:defRPr sz="2100" b="1">
                 <a:solidFill>
-                  <a:srgbClr val="FFFFFF"/>
+                  <a:srgbClr val="102C43"/>
                 </a:solidFill>
                 <a:latin typeface="Arial Unicode MS"/>
                 <a:ea typeface="Arial Unicode MS"/>
@@ -7760,7 +7760,7 @@
             <a:r>
               <a:rPr sz="2100" b="1">
                 <a:solidFill>
-                  <a:srgbClr val="FFFFFF"/>
+                  <a:srgbClr val="102C43"/>
                 </a:solidFill>
                 <a:latin typeface="Arial Unicode MS"/>
                 <a:ea typeface="Arial Unicode MS"/>
@@ -7806,7 +7806,7 @@
             <a:defPPr algn="ctr">
               <a:defRPr sz="1425" b="0">
                 <a:solidFill>
-                  <a:srgbClr val="DCEAF1"/>
+                  <a:srgbClr val="203849"/>
                 </a:solidFill>
                 <a:latin typeface="Arial Unicode MS"/>
                 <a:ea typeface="Arial Unicode MS"/>
@@ -7817,7 +7817,7 @@
               <a:buNone/>
               <a:defRPr sz="1425" b="0">
                 <a:solidFill>
-                  <a:srgbClr val="DCEAF1"/>
+                  <a:srgbClr val="203849"/>
                 </a:solidFill>
                 <a:latin typeface="Arial Unicode MS"/>
                 <a:ea typeface="Arial Unicode MS"/>
@@ -7828,7 +7828,7 @@
               <a:buNone/>
               <a:defRPr sz="1425" b="0">
                 <a:solidFill>
-                  <a:srgbClr val="DCEAF1"/>
+                  <a:srgbClr val="203849"/>
                 </a:solidFill>
                 <a:latin typeface="Arial Unicode MS"/>
                 <a:ea typeface="Arial Unicode MS"/>
@@ -7839,7 +7839,7 @@
               <a:buNone/>
               <a:defRPr sz="1425" b="0">
                 <a:solidFill>
-                  <a:srgbClr val="DCEAF1"/>
+                  <a:srgbClr val="203849"/>
                 </a:solidFill>
                 <a:latin typeface="Arial Unicode MS"/>
                 <a:ea typeface="Arial Unicode MS"/>
@@ -7850,7 +7850,7 @@
               <a:buNone/>
               <a:defRPr sz="1425" b="0">
                 <a:solidFill>
-                  <a:srgbClr val="DCEAF1"/>
+                  <a:srgbClr val="203849"/>
                 </a:solidFill>
                 <a:latin typeface="Arial Unicode MS"/>
                 <a:ea typeface="Arial Unicode MS"/>
@@ -7861,7 +7861,7 @@
               <a:buNone/>
               <a:defRPr sz="1425" b="0">
                 <a:solidFill>
-                  <a:srgbClr val="DCEAF1"/>
+                  <a:srgbClr val="203849"/>
                 </a:solidFill>
                 <a:latin typeface="Arial Unicode MS"/>
                 <a:ea typeface="Arial Unicode MS"/>
@@ -7872,7 +7872,7 @@
               <a:buNone/>
               <a:defRPr sz="1425" b="0">
                 <a:solidFill>
-                  <a:srgbClr val="DCEAF1"/>
+                  <a:srgbClr val="203849"/>
                 </a:solidFill>
                 <a:latin typeface="Arial Unicode MS"/>
                 <a:ea typeface="Arial Unicode MS"/>
@@ -7883,7 +7883,7 @@
               <a:buNone/>
               <a:defRPr sz="1425" b="0">
                 <a:solidFill>
-                  <a:srgbClr val="DCEAF1"/>
+                  <a:srgbClr val="203849"/>
                 </a:solidFill>
                 <a:latin typeface="Arial Unicode MS"/>
                 <a:ea typeface="Arial Unicode MS"/>
@@ -7894,7 +7894,7 @@
               <a:buNone/>
               <a:defRPr sz="1425" b="0">
                 <a:solidFill>
-                  <a:srgbClr val="DCEAF1"/>
+                  <a:srgbClr val="203849"/>
                 </a:solidFill>
                 <a:latin typeface="Arial Unicode MS"/>
                 <a:ea typeface="Arial Unicode MS"/>
@@ -7905,7 +7905,7 @@
               <a:buNone/>
               <a:defRPr sz="1425" b="0">
                 <a:solidFill>
-                  <a:srgbClr val="DCEAF1"/>
+                  <a:srgbClr val="203849"/>
                 </a:solidFill>
                 <a:latin typeface="Arial Unicode MS"/>
                 <a:ea typeface="Arial Unicode MS"/>
@@ -7918,7 +7918,7 @@
               <a:buNone/>
               <a:defRPr sz="1425" b="0">
                 <a:solidFill>
-                  <a:srgbClr val="DCEAF1"/>
+                  <a:srgbClr val="203849"/>
                 </a:solidFill>
                 <a:latin typeface="Arial Unicode MS"/>
                 <a:ea typeface="Arial Unicode MS"/>
@@ -7928,7 +7928,7 @@
             <a:r>
               <a:rPr sz="1425" b="0">
                 <a:solidFill>
-                  <a:srgbClr val="DCEAF1"/>
+                  <a:srgbClr val="203849"/>
                 </a:solidFill>
                 <a:latin typeface="Arial Unicode MS"/>
                 <a:ea typeface="Arial Unicode MS"/>
@@ -7961,7 +7961,7 @@
           </a:prstGeom>
           <a:ln xmlns:a="http://schemas.openxmlformats.org/drawingml/2006/main" w="19050">
             <a:solidFill>
-              <a:srgbClr val="ADC2D0"/>
+              <a:srgbClr val="566B79"/>
             </a:solidFill>
             <a:tailEnd type="none" w="sm" len="sm"/>
           </a:ln>
@@ -7989,7 +7989,7 @@
           </a:prstGeom>
           <a:ln xmlns:a="http://schemas.openxmlformats.org/drawingml/2006/main" w="19050">
             <a:solidFill>
-              <a:srgbClr val="ADC2D0"/>
+              <a:srgbClr val="566B79"/>
             </a:solidFill>
             <a:tailEnd type="none" w="sm" len="sm"/>
           </a:ln>
@@ -8017,7 +8017,7 @@
           </a:prstGeom>
           <a:ln xmlns:a="http://schemas.openxmlformats.org/drawingml/2006/main" w="19050">
             <a:solidFill>
-              <a:srgbClr val="ADC2D0"/>
+              <a:srgbClr val="566B79"/>
             </a:solidFill>
             <a:tailEnd type="triangle" w="sm" len="sm"/>
           </a:ln>
@@ -8058,7 +8058,7 @@
             <a:defPPr algn="ctr">
               <a:defRPr sz="1800" b="0">
                 <a:solidFill>
-                  <a:srgbClr val="EEC28B"/>
+                  <a:srgbClr val="9A641E"/>
                 </a:solidFill>
                 <a:latin typeface="Arial Unicode MS"/>
                 <a:ea typeface="Arial Unicode MS"/>
@@ -8069,7 +8069,7 @@
               <a:buNone/>
               <a:defRPr sz="1800" b="0">
                 <a:solidFill>
-                  <a:srgbClr val="EEC28B"/>
+                  <a:srgbClr val="9A641E"/>
                 </a:solidFill>
                 <a:latin typeface="Arial Unicode MS"/>
                 <a:ea typeface="Arial Unicode MS"/>
@@ -8080,7 +8080,7 @@
               <a:buNone/>
               <a:defRPr sz="1800" b="0">
                 <a:solidFill>
-                  <a:srgbClr val="EEC28B"/>
+                  <a:srgbClr val="9A641E"/>
                 </a:solidFill>
                 <a:latin typeface="Arial Unicode MS"/>
                 <a:ea typeface="Arial Unicode MS"/>
@@ -8091,7 +8091,7 @@
               <a:buNone/>
               <a:defRPr sz="1800" b="0">
                 <a:solidFill>
-                  <a:srgbClr val="EEC28B"/>
+                  <a:srgbClr val="9A641E"/>
                 </a:solidFill>
                 <a:latin typeface="Arial Unicode MS"/>
                 <a:ea typeface="Arial Unicode MS"/>
@@ -8102,7 +8102,7 @@
               <a:buNone/>
               <a:defRPr sz="1800" b="0">
                 <a:solidFill>
-                  <a:srgbClr val="EEC28B"/>
+                  <a:srgbClr val="9A641E"/>
                 </a:solidFill>
                 <a:latin typeface="Arial Unicode MS"/>
                 <a:ea typeface="Arial Unicode MS"/>
@@ -8113,7 +8113,7 @@
               <a:buNone/>
               <a:defRPr sz="1800" b="0">
                 <a:solidFill>
-                  <a:srgbClr val="EEC28B"/>
+                  <a:srgbClr val="9A641E"/>
                 </a:solidFill>
                 <a:latin typeface="Arial Unicode MS"/>
                 <a:ea typeface="Arial Unicode MS"/>
@@ -8124,7 +8124,7 @@
               <a:buNone/>
               <a:defRPr sz="1800" b="0">
                 <a:solidFill>
-                  <a:srgbClr val="EEC28B"/>
+                  <a:srgbClr val="9A641E"/>
                 </a:solidFill>
                 <a:latin typeface="Arial Unicode MS"/>
                 <a:ea typeface="Arial Unicode MS"/>
@@ -8135,7 +8135,7 @@
               <a:buNone/>
               <a:defRPr sz="1800" b="0">
                 <a:solidFill>
-                  <a:srgbClr val="EEC28B"/>
+                  <a:srgbClr val="9A641E"/>
                 </a:solidFill>
                 <a:latin typeface="Arial Unicode MS"/>
                 <a:ea typeface="Arial Unicode MS"/>
@@ -8146,7 +8146,7 @@
               <a:buNone/>
               <a:defRPr sz="1800" b="0">
                 <a:solidFill>
-                  <a:srgbClr val="EEC28B"/>
+                  <a:srgbClr val="9A641E"/>
                 </a:solidFill>
                 <a:latin typeface="Arial Unicode MS"/>
                 <a:ea typeface="Arial Unicode MS"/>
@@ -8157,7 +8157,7 @@
               <a:buNone/>
               <a:defRPr sz="1800" b="0">
                 <a:solidFill>
-                  <a:srgbClr val="EEC28B"/>
+                  <a:srgbClr val="9A641E"/>
                 </a:solidFill>
                 <a:latin typeface="Arial Unicode MS"/>
                 <a:ea typeface="Arial Unicode MS"/>
@@ -8170,7 +8170,7 @@
               <a:buNone/>
               <a:defRPr sz="1800" b="0">
                 <a:solidFill>
-                  <a:srgbClr val="EEC28B"/>
+                  <a:srgbClr val="9A641E"/>
                 </a:solidFill>
                 <a:latin typeface="Arial Unicode MS"/>
                 <a:ea typeface="Arial Unicode MS"/>
@@ -8180,7 +8180,7 @@
             <a:r>
               <a:rPr sz="1800" b="0">
                 <a:solidFill>
-                  <a:srgbClr val="EEC28B"/>
+                  <a:srgbClr val="9A641E"/>
                 </a:solidFill>
                 <a:latin typeface="Arial Unicode MS"/>
                 <a:ea typeface="Arial Unicode MS"/>
@@ -8226,7 +8226,7 @@
             <a:defPPr algn="l">
               <a:defRPr sz="2325" b="1">
                 <a:solidFill>
-                  <a:srgbClr val="FFFFFF"/>
+                  <a:srgbClr val="102C43"/>
                 </a:solidFill>
                 <a:latin typeface="Arial Unicode MS"/>
                 <a:ea typeface="Arial Unicode MS"/>
@@ -8237,7 +8237,7 @@
               <a:buNone/>
               <a:defRPr sz="2325" b="1">
                 <a:solidFill>
-                  <a:srgbClr val="FFFFFF"/>
+                  <a:srgbClr val="102C43"/>
                 </a:solidFill>
                 <a:latin typeface="Arial Unicode MS"/>
                 <a:ea typeface="Arial Unicode MS"/>
@@ -8248,7 +8248,7 @@
               <a:buNone/>
               <a:defRPr sz="2325" b="1">
                 <a:solidFill>
-                  <a:srgbClr val="FFFFFF"/>
+                  <a:srgbClr val="102C43"/>
                 </a:solidFill>
                 <a:latin typeface="Arial Unicode MS"/>
                 <a:ea typeface="Arial Unicode MS"/>
@@ -8259,7 +8259,7 @@
               <a:buNone/>
               <a:defRPr sz="2325" b="1">
                 <a:solidFill>
-                  <a:srgbClr val="FFFFFF"/>
+                  <a:srgbClr val="102C43"/>
                 </a:solidFill>
                 <a:latin typeface="Arial Unicode MS"/>
                 <a:ea typeface="Arial Unicode MS"/>
@@ -8270,7 +8270,7 @@
               <a:buNone/>
               <a:defRPr sz="2325" b="1">
                 <a:solidFill>
-                  <a:srgbClr val="FFFFFF"/>
+                  <a:srgbClr val="102C43"/>
                 </a:solidFill>
                 <a:latin typeface="Arial Unicode MS"/>
                 <a:ea typeface="Arial Unicode MS"/>
@@ -8281,7 +8281,7 @@
               <a:buNone/>
               <a:defRPr sz="2325" b="1">
                 <a:solidFill>
-                  <a:srgbClr val="FFFFFF"/>
+                  <a:srgbClr val="102C43"/>
                 </a:solidFill>
                 <a:latin typeface="Arial Unicode MS"/>
                 <a:ea typeface="Arial Unicode MS"/>
@@ -8292,7 +8292,7 @@
               <a:buNone/>
               <a:defRPr sz="2325" b="1">
                 <a:solidFill>
-                  <a:srgbClr val="FFFFFF"/>
+                  <a:srgbClr val="102C43"/>
                 </a:solidFill>
                 <a:latin typeface="Arial Unicode MS"/>
                 <a:ea typeface="Arial Unicode MS"/>
@@ -8303,7 +8303,7 @@
               <a:buNone/>
               <a:defRPr sz="2325" b="1">
                 <a:solidFill>
-                  <a:srgbClr val="FFFFFF"/>
+                  <a:srgbClr val="102C43"/>
                 </a:solidFill>
                 <a:latin typeface="Arial Unicode MS"/>
                 <a:ea typeface="Arial Unicode MS"/>
@@ -8314,7 +8314,7 @@
               <a:buNone/>
               <a:defRPr sz="2325" b="1">
                 <a:solidFill>
-                  <a:srgbClr val="FFFFFF"/>
+                  <a:srgbClr val="102C43"/>
                 </a:solidFill>
                 <a:latin typeface="Arial Unicode MS"/>
                 <a:ea typeface="Arial Unicode MS"/>
@@ -8325,7 +8325,7 @@
               <a:buNone/>
               <a:defRPr sz="2325" b="1">
                 <a:solidFill>
-                  <a:srgbClr val="FFFFFF"/>
+                  <a:srgbClr val="102C43"/>
                 </a:solidFill>
                 <a:latin typeface="Arial Unicode MS"/>
                 <a:ea typeface="Arial Unicode MS"/>
@@ -8338,7 +8338,7 @@
               <a:buNone/>
               <a:defRPr sz="2325" b="1">
                 <a:solidFill>
-                  <a:srgbClr val="FFFFFF"/>
+                  <a:srgbClr val="102C43"/>
                 </a:solidFill>
                 <a:latin typeface="Arial Unicode MS"/>
                 <a:ea typeface="Arial Unicode MS"/>
@@ -8348,7 +8348,7 @@
             <a:r>
               <a:rPr sz="2325" b="1">
                 <a:solidFill>
-                  <a:srgbClr val="FFFFFF"/>
+                  <a:srgbClr val="102C43"/>
                 </a:solidFill>
                 <a:latin typeface="Arial Unicode MS"/>
                 <a:ea typeface="Arial Unicode MS"/>
@@ -8394,7 +8394,7 @@
             <a:defPPr algn="l">
               <a:defRPr sz="2025" b="1">
                 <a:solidFill>
-                  <a:srgbClr val="EEC28B"/>
+                  <a:srgbClr val="9A641E"/>
                 </a:solidFill>
                 <a:latin typeface="Arial Unicode MS"/>
                 <a:ea typeface="Arial Unicode MS"/>
@@ -8405,7 +8405,7 @@
               <a:buNone/>
               <a:defRPr sz="2025" b="1">
                 <a:solidFill>
-                  <a:srgbClr val="EEC28B"/>
+                  <a:srgbClr val="9A641E"/>
                 </a:solidFill>
                 <a:latin typeface="Arial Unicode MS"/>
                 <a:ea typeface="Arial Unicode MS"/>
@@ -8416,7 +8416,7 @@
               <a:buNone/>
               <a:defRPr sz="2025" b="1">
                 <a:solidFill>
-                  <a:srgbClr val="EEC28B"/>
+                  <a:srgbClr val="9A641E"/>
                 </a:solidFill>
                 <a:latin typeface="Arial Unicode MS"/>
                 <a:ea typeface="Arial Unicode MS"/>
@@ -8427,7 +8427,7 @@
               <a:buNone/>
               <a:defRPr sz="2025" b="1">
                 <a:solidFill>
-                  <a:srgbClr val="EEC28B"/>
+                  <a:srgbClr val="9A641E"/>
                 </a:solidFill>
                 <a:latin typeface="Arial Unicode MS"/>
                 <a:ea typeface="Arial Unicode MS"/>
@@ -8438,7 +8438,7 @@
               <a:buNone/>
               <a:defRPr sz="2025" b="1">
                 <a:solidFill>
-                  <a:srgbClr val="EEC28B"/>
+                  <a:srgbClr val="9A641E"/>
                 </a:solidFill>
                 <a:latin typeface="Arial Unicode MS"/>
                 <a:ea typeface="Arial Unicode MS"/>
@@ -8449,7 +8449,7 @@
               <a:buNone/>
               <a:defRPr sz="2025" b="1">
                 <a:solidFill>
-                  <a:srgbClr val="EEC28B"/>
+                  <a:srgbClr val="9A641E"/>
                 </a:solidFill>
                 <a:latin typeface="Arial Unicode MS"/>
                 <a:ea typeface="Arial Unicode MS"/>
@@ -8460,7 +8460,7 @@
               <a:buNone/>
               <a:defRPr sz="2025" b="1">
                 <a:solidFill>
-                  <a:srgbClr val="EEC28B"/>
+                  <a:srgbClr val="9A641E"/>
                 </a:solidFill>
                 <a:latin typeface="Arial Unicode MS"/>
                 <a:ea typeface="Arial Unicode MS"/>
@@ -8471,7 +8471,7 @@
               <a:buNone/>
               <a:defRPr sz="2025" b="1">
                 <a:solidFill>
-                  <a:srgbClr val="EEC28B"/>
+                  <a:srgbClr val="9A641E"/>
                 </a:solidFill>
                 <a:latin typeface="Arial Unicode MS"/>
                 <a:ea typeface="Arial Unicode MS"/>
@@ -8482,7 +8482,7 @@
               <a:buNone/>
               <a:defRPr sz="2025" b="1">
                 <a:solidFill>
-                  <a:srgbClr val="EEC28B"/>
+                  <a:srgbClr val="9A641E"/>
                 </a:solidFill>
                 <a:latin typeface="Arial Unicode MS"/>
                 <a:ea typeface="Arial Unicode MS"/>
@@ -8493,7 +8493,7 @@
               <a:buNone/>
               <a:defRPr sz="2025" b="1">
                 <a:solidFill>
-                  <a:srgbClr val="EEC28B"/>
+                  <a:srgbClr val="9A641E"/>
                 </a:solidFill>
                 <a:latin typeface="Arial Unicode MS"/>
                 <a:ea typeface="Arial Unicode MS"/>
@@ -8506,7 +8506,7 @@
               <a:buNone/>
               <a:defRPr sz="2025" b="1">
                 <a:solidFill>
-                  <a:srgbClr val="EEC28B"/>
+                  <a:srgbClr val="9A641E"/>
                 </a:solidFill>
                 <a:latin typeface="Arial Unicode MS"/>
                 <a:ea typeface="Arial Unicode MS"/>
@@ -8516,7 +8516,7 @@
             <a:r>
               <a:rPr sz="2025" b="1">
                 <a:solidFill>
-                  <a:srgbClr val="EEC28B"/>
+                  <a:srgbClr val="9A641E"/>
                 </a:solidFill>
                 <a:latin typeface="Arial Unicode MS"/>
                 <a:ea typeface="Arial Unicode MS"/>
@@ -8562,7 +8562,7 @@
             <a:defPPr algn="l">
               <a:defRPr sz="1725" b="0">
                 <a:solidFill>
-                  <a:srgbClr val="DCEAF1"/>
+                  <a:srgbClr val="203849"/>
                 </a:solidFill>
                 <a:latin typeface="Arial Unicode MS"/>
                 <a:ea typeface="Arial Unicode MS"/>
@@ -8573,7 +8573,7 @@
               <a:buNone/>
               <a:defRPr sz="1725" b="0">
                 <a:solidFill>
-                  <a:srgbClr val="DCEAF1"/>
+                  <a:srgbClr val="203849"/>
                 </a:solidFill>
                 <a:latin typeface="Arial Unicode MS"/>
                 <a:ea typeface="Arial Unicode MS"/>
@@ -8584,7 +8584,7 @@
               <a:buNone/>
               <a:defRPr sz="1725" b="0">
                 <a:solidFill>
-                  <a:srgbClr val="DCEAF1"/>
+                  <a:srgbClr val="203849"/>
                 </a:solidFill>
                 <a:latin typeface="Arial Unicode MS"/>
                 <a:ea typeface="Arial Unicode MS"/>
@@ -8595,7 +8595,7 @@
               <a:buNone/>
               <a:defRPr sz="1725" b="0">
                 <a:solidFill>
-                  <a:srgbClr val="DCEAF1"/>
+                  <a:srgbClr val="203849"/>
                 </a:solidFill>
                 <a:latin typeface="Arial Unicode MS"/>
                 <a:ea typeface="Arial Unicode MS"/>
@@ -8606,7 +8606,7 @@
               <a:buNone/>
               <a:defRPr sz="1725" b="0">
                 <a:solidFill>
-                  <a:srgbClr val="DCEAF1"/>
+                  <a:srgbClr val="203849"/>
                 </a:solidFill>
                 <a:latin typeface="Arial Unicode MS"/>
                 <a:ea typeface="Arial Unicode MS"/>
@@ -8617,7 +8617,7 @@
               <a:buNone/>
               <a:defRPr sz="1725" b="0">
                 <a:solidFill>
-                  <a:srgbClr val="DCEAF1"/>
+                  <a:srgbClr val="203849"/>
                 </a:solidFill>
                 <a:latin typeface="Arial Unicode MS"/>
                 <a:ea typeface="Arial Unicode MS"/>
@@ -8628,7 +8628,7 @@
               <a:buNone/>
               <a:defRPr sz="1725" b="0">
                 <a:solidFill>
-                  <a:srgbClr val="DCEAF1"/>
+                  <a:srgbClr val="203849"/>
                 </a:solidFill>
                 <a:latin typeface="Arial Unicode MS"/>
                 <a:ea typeface="Arial Unicode MS"/>
@@ -8639,7 +8639,7 @@
               <a:buNone/>
               <a:defRPr sz="1725" b="0">
                 <a:solidFill>
-                  <a:srgbClr val="DCEAF1"/>
+                  <a:srgbClr val="203849"/>
                 </a:solidFill>
                 <a:latin typeface="Arial Unicode MS"/>
                 <a:ea typeface="Arial Unicode MS"/>
@@ -8650,7 +8650,7 @@
               <a:buNone/>
               <a:defRPr sz="1725" b="0">
                 <a:solidFill>
-                  <a:srgbClr val="DCEAF1"/>
+                  <a:srgbClr val="203849"/>
                 </a:solidFill>
                 <a:latin typeface="Arial Unicode MS"/>
                 <a:ea typeface="Arial Unicode MS"/>
@@ -8661,7 +8661,7 @@
               <a:buNone/>
               <a:defRPr sz="1725" b="0">
                 <a:solidFill>
-                  <a:srgbClr val="DCEAF1"/>
+                  <a:srgbClr val="203849"/>
                 </a:solidFill>
                 <a:latin typeface="Arial Unicode MS"/>
                 <a:ea typeface="Arial Unicode MS"/>
@@ -8674,7 +8674,7 @@
               <a:buNone/>
               <a:defRPr sz="1725" b="0">
                 <a:solidFill>
-                  <a:srgbClr val="DCEAF1"/>
+                  <a:srgbClr val="203849"/>
                 </a:solidFill>
                 <a:latin typeface="Arial Unicode MS"/>
                 <a:ea typeface="Arial Unicode MS"/>
@@ -8684,7 +8684,7 @@
             <a:r>
               <a:rPr sz="1725" b="0">
                 <a:solidFill>
-                  <a:srgbClr val="DCEAF1"/>
+                  <a:srgbClr val="203849"/>
                 </a:solidFill>
                 <a:latin typeface="Arial Unicode MS"/>
                 <a:ea typeface="Arial Unicode MS"/>
@@ -8717,7 +8717,7 @@
           </a:prstGeom>
           <a:ln xmlns:a="http://schemas.openxmlformats.org/drawingml/2006/main" w="9525">
             <a:solidFill>
-              <a:srgbClr val="587386"/>
+              <a:srgbClr val="9BADB8"/>
             </a:solidFill>
             <a:tailEnd type="none" w="sm" len="sm"/>
           </a:ln>
@@ -8758,7 +8758,7 @@
             <a:defPPr algn="l">
               <a:defRPr sz="2025" b="1">
                 <a:solidFill>
-                  <a:srgbClr val="81D9D1"/>
+                  <a:srgbClr val="007F83"/>
                 </a:solidFill>
                 <a:latin typeface="Arial Unicode MS"/>
                 <a:ea typeface="Arial Unicode MS"/>
@@ -8769,7 +8769,7 @@
               <a:buNone/>
               <a:defRPr sz="2025" b="1">
                 <a:solidFill>
-                  <a:srgbClr val="81D9D1"/>
+                  <a:srgbClr val="007F83"/>
                 </a:solidFill>
                 <a:latin typeface="Arial Unicode MS"/>
                 <a:ea typeface="Arial Unicode MS"/>
@@ -8780,7 +8780,7 @@
               <a:buNone/>
               <a:defRPr sz="2025" b="1">
                 <a:solidFill>
-                  <a:srgbClr val="81D9D1"/>
+                  <a:srgbClr val="007F83"/>
                 </a:solidFill>
                 <a:latin typeface="Arial Unicode MS"/>
                 <a:ea typeface="Arial Unicode MS"/>
@@ -8791,7 +8791,7 @@
               <a:buNone/>
               <a:defRPr sz="2025" b="1">
                 <a:solidFill>
-                  <a:srgbClr val="81D9D1"/>
+                  <a:srgbClr val="007F83"/>
                 </a:solidFill>
                 <a:latin typeface="Arial Unicode MS"/>
                 <a:ea typeface="Arial Unicode MS"/>
@@ -8802,7 +8802,7 @@
               <a:buNone/>
               <a:defRPr sz="2025" b="1">
                 <a:solidFill>
-                  <a:srgbClr val="81D9D1"/>
+                  <a:srgbClr val="007F83"/>
                 </a:solidFill>
                 <a:latin typeface="Arial Unicode MS"/>
                 <a:ea typeface="Arial Unicode MS"/>
@@ -8813,7 +8813,7 @@
               <a:buNone/>
               <a:defRPr sz="2025" b="1">
                 <a:solidFill>
-                  <a:srgbClr val="81D9D1"/>
+                  <a:srgbClr val="007F83"/>
                 </a:solidFill>
                 <a:latin typeface="Arial Unicode MS"/>
                 <a:ea typeface="Arial Unicode MS"/>
@@ -8824,7 +8824,7 @@
               <a:buNone/>
               <a:defRPr sz="2025" b="1">
                 <a:solidFill>
-                  <a:srgbClr val="81D9D1"/>
+                  <a:srgbClr val="007F83"/>
                 </a:solidFill>
                 <a:latin typeface="Arial Unicode MS"/>
                 <a:ea typeface="Arial Unicode MS"/>
@@ -8835,7 +8835,7 @@
               <a:buNone/>
               <a:defRPr sz="2025" b="1">
                 <a:solidFill>
-                  <a:srgbClr val="81D9D1"/>
+                  <a:srgbClr val="007F83"/>
                 </a:solidFill>
                 <a:latin typeface="Arial Unicode MS"/>
                 <a:ea typeface="Arial Unicode MS"/>
@@ -8846,7 +8846,7 @@
               <a:buNone/>
               <a:defRPr sz="2025" b="1">
                 <a:solidFill>
-                  <a:srgbClr val="81D9D1"/>
+                  <a:srgbClr val="007F83"/>
                 </a:solidFill>
                 <a:latin typeface="Arial Unicode MS"/>
                 <a:ea typeface="Arial Unicode MS"/>
@@ -8857,7 +8857,7 @@
               <a:buNone/>
               <a:defRPr sz="2025" b="1">
                 <a:solidFill>
-                  <a:srgbClr val="81D9D1"/>
+                  <a:srgbClr val="007F83"/>
                 </a:solidFill>
                 <a:latin typeface="Arial Unicode MS"/>
                 <a:ea typeface="Arial Unicode MS"/>
@@ -8870,7 +8870,7 @@
               <a:buNone/>
               <a:defRPr sz="2025" b="1">
                 <a:solidFill>
-                  <a:srgbClr val="81D9D1"/>
+                  <a:srgbClr val="007F83"/>
                 </a:solidFill>
                 <a:latin typeface="Arial Unicode MS"/>
                 <a:ea typeface="Arial Unicode MS"/>
@@ -8880,7 +8880,7 @@
             <a:r>
               <a:rPr sz="2025" b="1">
                 <a:solidFill>
-                  <a:srgbClr val="81D9D1"/>
+                  <a:srgbClr val="007F83"/>
                 </a:solidFill>
                 <a:latin typeface="Arial Unicode MS"/>
                 <a:ea typeface="Arial Unicode MS"/>
@@ -8926,7 +8926,7 @@
             <a:defPPr algn="l">
               <a:defRPr sz="1725" b="0">
                 <a:solidFill>
-                  <a:srgbClr val="DCEAF1"/>
+                  <a:srgbClr val="203849"/>
                 </a:solidFill>
                 <a:latin typeface="Arial Unicode MS"/>
                 <a:ea typeface="Arial Unicode MS"/>
@@ -8937,7 +8937,7 @@
               <a:buNone/>
               <a:defRPr sz="1725" b="0">
                 <a:solidFill>
-                  <a:srgbClr val="DCEAF1"/>
+                  <a:srgbClr val="203849"/>
                 </a:solidFill>
                 <a:latin typeface="Arial Unicode MS"/>
                 <a:ea typeface="Arial Unicode MS"/>
@@ -8948,7 +8948,7 @@
               <a:buNone/>
               <a:defRPr sz="1725" b="0">
                 <a:solidFill>
-                  <a:srgbClr val="DCEAF1"/>
+                  <a:srgbClr val="203849"/>
                 </a:solidFill>
                 <a:latin typeface="Arial Unicode MS"/>
                 <a:ea typeface="Arial Unicode MS"/>
@@ -8959,7 +8959,7 @@
               <a:buNone/>
               <a:defRPr sz="1725" b="0">
                 <a:solidFill>
-                  <a:srgbClr val="DCEAF1"/>
+                  <a:srgbClr val="203849"/>
                 </a:solidFill>
                 <a:latin typeface="Arial Unicode MS"/>
                 <a:ea typeface="Arial Unicode MS"/>
@@ -8970,7 +8970,7 @@
               <a:buNone/>
               <a:defRPr sz="1725" b="0">
                 <a:solidFill>
-                  <a:srgbClr val="DCEAF1"/>
+                  <a:srgbClr val="203849"/>
                 </a:solidFill>
                 <a:latin typeface="Arial Unicode MS"/>
                 <a:ea typeface="Arial Unicode MS"/>
@@ -8981,7 +8981,7 @@
               <a:buNone/>
               <a:defRPr sz="1725" b="0">
                 <a:solidFill>
-                  <a:srgbClr val="DCEAF1"/>
+                  <a:srgbClr val="203849"/>
                 </a:solidFill>
                 <a:latin typeface="Arial Unicode MS"/>
                 <a:ea typeface="Arial Unicode MS"/>
@@ -8992,7 +8992,7 @@
               <a:buNone/>
               <a:defRPr sz="1725" b="0">
                 <a:solidFill>
-                  <a:srgbClr val="DCEAF1"/>
+                  <a:srgbClr val="203849"/>
                 </a:solidFill>
                 <a:latin typeface="Arial Unicode MS"/>
                 <a:ea typeface="Arial Unicode MS"/>
@@ -9003,7 +9003,7 @@
               <a:buNone/>
               <a:defRPr sz="1725" b="0">
                 <a:solidFill>
-                  <a:srgbClr val="DCEAF1"/>
+                  <a:srgbClr val="203849"/>
                 </a:solidFill>
                 <a:latin typeface="Arial Unicode MS"/>
                 <a:ea typeface="Arial Unicode MS"/>
@@ -9014,7 +9014,7 @@
               <a:buNone/>
               <a:defRPr sz="1725" b="0">
                 <a:solidFill>
-                  <a:srgbClr val="DCEAF1"/>
+                  <a:srgbClr val="203849"/>
                 </a:solidFill>
                 <a:latin typeface="Arial Unicode MS"/>
                 <a:ea typeface="Arial Unicode MS"/>
@@ -9025,7 +9025,7 @@
               <a:buNone/>
               <a:defRPr sz="1725" b="0">
                 <a:solidFill>
-                  <a:srgbClr val="DCEAF1"/>
+                  <a:srgbClr val="203849"/>
                 </a:solidFill>
                 <a:latin typeface="Arial Unicode MS"/>
                 <a:ea typeface="Arial Unicode MS"/>
@@ -9038,7 +9038,7 @@
               <a:buNone/>
               <a:defRPr sz="1725" b="0">
                 <a:solidFill>
-                  <a:srgbClr val="DCEAF1"/>
+                  <a:srgbClr val="203849"/>
                 </a:solidFill>
                 <a:latin typeface="Arial Unicode MS"/>
                 <a:ea typeface="Arial Unicode MS"/>
@@ -9048,7 +9048,7 @@
             <a:r>
               <a:rPr sz="1725" b="0">
                 <a:solidFill>
-                  <a:srgbClr val="DCEAF1"/>
+                  <a:srgbClr val="203849"/>
                 </a:solidFill>
                 <a:latin typeface="Arial Unicode MS"/>
                 <a:ea typeface="Arial Unicode MS"/>
@@ -9062,7 +9062,7 @@
               <a:buNone/>
               <a:defRPr sz="1725" b="0">
                 <a:solidFill>
-                  <a:srgbClr val="DCEAF1"/>
+                  <a:srgbClr val="203849"/>
                 </a:solidFill>
                 <a:latin typeface="Arial Unicode MS"/>
                 <a:ea typeface="Arial Unicode MS"/>
@@ -9072,7 +9072,7 @@
             <a:r>
               <a:rPr sz="1725" b="0">
                 <a:solidFill>
-                  <a:srgbClr val="DCEAF1"/>
+                  <a:srgbClr val="203849"/>
                 </a:solidFill>
                 <a:latin typeface="Arial Unicode MS"/>
                 <a:ea typeface="Arial Unicode MS"/>
@@ -9118,7 +9118,7 @@
             <a:defPPr algn="l">
               <a:defRPr sz="2025" b="1">
                 <a:solidFill>
-                  <a:srgbClr val="EEC28B"/>
+                  <a:srgbClr val="9A641E"/>
                 </a:solidFill>
                 <a:latin typeface="Arial Unicode MS"/>
                 <a:ea typeface="Arial Unicode MS"/>
@@ -9129,7 +9129,7 @@
               <a:buNone/>
               <a:defRPr sz="2025" b="1">
                 <a:solidFill>
-                  <a:srgbClr val="EEC28B"/>
+                  <a:srgbClr val="9A641E"/>
                 </a:solidFill>
                 <a:latin typeface="Arial Unicode MS"/>
                 <a:ea typeface="Arial Unicode MS"/>
@@ -9140,7 +9140,7 @@
               <a:buNone/>
               <a:defRPr sz="2025" b="1">
                 <a:solidFill>
-                  <a:srgbClr val="EEC28B"/>
+                  <a:srgbClr val="9A641E"/>
                 </a:solidFill>
                 <a:latin typeface="Arial Unicode MS"/>
                 <a:ea typeface="Arial Unicode MS"/>
@@ -9151,7 +9151,7 @@
               <a:buNone/>
               <a:defRPr sz="2025" b="1">
                 <a:solidFill>
-                  <a:srgbClr val="EEC28B"/>
+                  <a:srgbClr val="9A641E"/>
                 </a:solidFill>
                 <a:latin typeface="Arial Unicode MS"/>
                 <a:ea typeface="Arial Unicode MS"/>
@@ -9162,7 +9162,7 @@
               <a:buNone/>
               <a:defRPr sz="2025" b="1">
                 <a:solidFill>
-                  <a:srgbClr val="EEC28B"/>
+                  <a:srgbClr val="9A641E"/>
                 </a:solidFill>
                 <a:latin typeface="Arial Unicode MS"/>
                 <a:ea typeface="Arial Unicode MS"/>
@@ -9173,7 +9173,7 @@
               <a:buNone/>
               <a:defRPr sz="2025" b="1">
                 <a:solidFill>
-                  <a:srgbClr val="EEC28B"/>
+                  <a:srgbClr val="9A641E"/>
                 </a:solidFill>
                 <a:latin typeface="Arial Unicode MS"/>
                 <a:ea typeface="Arial Unicode MS"/>
@@ -9184,7 +9184,7 @@
               <a:buNone/>
               <a:defRPr sz="2025" b="1">
                 <a:solidFill>
-                  <a:srgbClr val="EEC28B"/>
+                  <a:srgbClr val="9A641E"/>
                 </a:solidFill>
                 <a:latin typeface="Arial Unicode MS"/>
                 <a:ea typeface="Arial Unicode MS"/>
@@ -9195,7 +9195,7 @@
               <a:buNone/>
               <a:defRPr sz="2025" b="1">
                 <a:solidFill>
-                  <a:srgbClr val="EEC28B"/>
+                  <a:srgbClr val="9A641E"/>
                 </a:solidFill>
                 <a:latin typeface="Arial Unicode MS"/>
                 <a:ea typeface="Arial Unicode MS"/>
@@ -9206,7 +9206,7 @@
               <a:buNone/>
               <a:defRPr sz="2025" b="1">
                 <a:solidFill>
-                  <a:srgbClr val="EEC28B"/>
+                  <a:srgbClr val="9A641E"/>
                 </a:solidFill>
                 <a:latin typeface="Arial Unicode MS"/>
                 <a:ea typeface="Arial Unicode MS"/>
@@ -9217,7 +9217,7 @@
               <a:buNone/>
               <a:defRPr sz="2025" b="1">
                 <a:solidFill>
-                  <a:srgbClr val="EEC28B"/>
+                  <a:srgbClr val="9A641E"/>
                 </a:solidFill>
                 <a:latin typeface="Arial Unicode MS"/>
                 <a:ea typeface="Arial Unicode MS"/>
@@ -9230,7 +9230,7 @@
               <a:buNone/>
               <a:defRPr sz="2025" b="1">
                 <a:solidFill>
-                  <a:srgbClr val="EEC28B"/>
+                  <a:srgbClr val="9A641E"/>
                 </a:solidFill>
                 <a:latin typeface="Arial Unicode MS"/>
                 <a:ea typeface="Arial Unicode MS"/>
@@ -9240,7 +9240,7 @@
             <a:r>
               <a:rPr sz="2025" b="1">
                 <a:solidFill>
-                  <a:srgbClr val="EEC28B"/>
+                  <a:srgbClr val="9A641E"/>
                 </a:solidFill>
                 <a:latin typeface="Arial Unicode MS"/>
                 <a:ea typeface="Arial Unicode MS"/>
@@ -9286,7 +9286,7 @@
             <a:defPPr algn="l">
               <a:defRPr sz="1725" b="0">
                 <a:solidFill>
-                  <a:srgbClr val="DCEAF1"/>
+                  <a:srgbClr val="203849"/>
                 </a:solidFill>
                 <a:latin typeface="Arial Unicode MS"/>
                 <a:ea typeface="Arial Unicode MS"/>
@@ -9297,7 +9297,7 @@
               <a:buNone/>
               <a:defRPr sz="1725" b="0">
                 <a:solidFill>
-                  <a:srgbClr val="DCEAF1"/>
+                  <a:srgbClr val="203849"/>
                 </a:solidFill>
                 <a:latin typeface="Arial Unicode MS"/>
                 <a:ea typeface="Arial Unicode MS"/>
@@ -9308,7 +9308,7 @@
               <a:buNone/>
               <a:defRPr sz="1725" b="0">
                 <a:solidFill>
-                  <a:srgbClr val="DCEAF1"/>
+                  <a:srgbClr val="203849"/>
                 </a:solidFill>
                 <a:latin typeface="Arial Unicode MS"/>
                 <a:ea typeface="Arial Unicode MS"/>
@@ -9319,7 +9319,7 @@
               <a:buNone/>
               <a:defRPr sz="1725" b="0">
                 <a:solidFill>
-                  <a:srgbClr val="DCEAF1"/>
+                  <a:srgbClr val="203849"/>
                 </a:solidFill>
                 <a:latin typeface="Arial Unicode MS"/>
                 <a:ea typeface="Arial Unicode MS"/>
@@ -9330,7 +9330,7 @@
               <a:buNone/>
               <a:defRPr sz="1725" b="0">
                 <a:solidFill>
-                  <a:srgbClr val="DCEAF1"/>
+                  <a:srgbClr val="203849"/>
                 </a:solidFill>
                 <a:latin typeface="Arial Unicode MS"/>
                 <a:ea typeface="Arial Unicode MS"/>
@@ -9341,7 +9341,7 @@
               <a:buNone/>
               <a:defRPr sz="1725" b="0">
                 <a:solidFill>
-                  <a:srgbClr val="DCEAF1"/>
+                  <a:srgbClr val="203849"/>
                 </a:solidFill>
                 <a:latin typeface="Arial Unicode MS"/>
                 <a:ea typeface="Arial Unicode MS"/>
@@ -9352,7 +9352,7 @@
               <a:buNone/>
               <a:defRPr sz="1725" b="0">
                 <a:solidFill>
-                  <a:srgbClr val="DCEAF1"/>
+                  <a:srgbClr val="203849"/>
                 </a:solidFill>
                 <a:latin typeface="Arial Unicode MS"/>
                 <a:ea typeface="Arial Unicode MS"/>
@@ -9363,7 +9363,7 @@
               <a:buNone/>
               <a:defRPr sz="1725" b="0">
                 <a:solidFill>
-                  <a:srgbClr val="DCEAF1"/>
+                  <a:srgbClr val="203849"/>
                 </a:solidFill>
                 <a:latin typeface="Arial Unicode MS"/>
                 <a:ea typeface="Arial Unicode MS"/>
@@ -9374,7 +9374,7 @@
               <a:buNone/>
               <a:defRPr sz="1725" b="0">
                 <a:solidFill>
-                  <a:srgbClr val="DCEAF1"/>
+                  <a:srgbClr val="203849"/>
                 </a:solidFill>
                 <a:latin typeface="Arial Unicode MS"/>
                 <a:ea typeface="Arial Unicode MS"/>
@@ -9385,7 +9385,7 @@
               <a:buNone/>
               <a:defRPr sz="1725" b="0">
                 <a:solidFill>
-                  <a:srgbClr val="DCEAF1"/>
+                  <a:srgbClr val="203849"/>
                 </a:solidFill>
                 <a:latin typeface="Arial Unicode MS"/>
                 <a:ea typeface="Arial Unicode MS"/>
@@ -9398,7 +9398,7 @@
               <a:buNone/>
               <a:defRPr sz="1725" b="0">
                 <a:solidFill>
-                  <a:srgbClr val="DCEAF1"/>
+                  <a:srgbClr val="203849"/>
                 </a:solidFill>
                 <a:latin typeface="Arial Unicode MS"/>
                 <a:ea typeface="Arial Unicode MS"/>
@@ -9408,7 +9408,7 @@
             <a:r>
               <a:rPr sz="1725" b="0">
                 <a:solidFill>
-                  <a:srgbClr val="DCEAF1"/>
+                  <a:srgbClr val="203849"/>
                 </a:solidFill>
                 <a:latin typeface="Arial Unicode MS"/>
                 <a:ea typeface="Arial Unicode MS"/>
@@ -9441,7 +9441,7 @@
           </a:prstGeom>
           <a:ln xmlns:a="http://schemas.openxmlformats.org/drawingml/2006/main" w="9525">
             <a:solidFill>
-              <a:srgbClr val="587386"/>
+              <a:srgbClr val="9BADB8"/>
             </a:solidFill>
             <a:tailEnd type="none" w="sm" len="sm"/>
           </a:ln>
@@ -9482,7 +9482,7 @@
             <a:defPPr algn="l">
               <a:defRPr sz="2025" b="1">
                 <a:solidFill>
-                  <a:srgbClr val="81D9D1"/>
+                  <a:srgbClr val="007F83"/>
                 </a:solidFill>
                 <a:latin typeface="Arial Unicode MS"/>
                 <a:ea typeface="Arial Unicode MS"/>
@@ -9493,7 +9493,7 @@
               <a:buNone/>
               <a:defRPr sz="2025" b="1">
                 <a:solidFill>
-                  <a:srgbClr val="81D9D1"/>
+                  <a:srgbClr val="007F83"/>
                 </a:solidFill>
                 <a:latin typeface="Arial Unicode MS"/>
                 <a:ea typeface="Arial Unicode MS"/>
@@ -9504,7 +9504,7 @@
               <a:buNone/>
               <a:defRPr sz="2025" b="1">
                 <a:solidFill>
-                  <a:srgbClr val="81D9D1"/>
+                  <a:srgbClr val="007F83"/>
                 </a:solidFill>
                 <a:latin typeface="Arial Unicode MS"/>
                 <a:ea typeface="Arial Unicode MS"/>
@@ -9515,7 +9515,7 @@
               <a:buNone/>
               <a:defRPr sz="2025" b="1">
                 <a:solidFill>
-                  <a:srgbClr val="81D9D1"/>
+                  <a:srgbClr val="007F83"/>
                 </a:solidFill>
                 <a:latin typeface="Arial Unicode MS"/>
                 <a:ea typeface="Arial Unicode MS"/>
@@ -9526,7 +9526,7 @@
               <a:buNone/>
               <a:defRPr sz="2025" b="1">
                 <a:solidFill>
-                  <a:srgbClr val="81D9D1"/>
+                  <a:srgbClr val="007F83"/>
                 </a:solidFill>
                 <a:latin typeface="Arial Unicode MS"/>
                 <a:ea typeface="Arial Unicode MS"/>
@@ -9537,7 +9537,7 @@
               <a:buNone/>
               <a:defRPr sz="2025" b="1">
                 <a:solidFill>
-                  <a:srgbClr val="81D9D1"/>
+                  <a:srgbClr val="007F83"/>
                 </a:solidFill>
                 <a:latin typeface="Arial Unicode MS"/>
                 <a:ea typeface="Arial Unicode MS"/>
@@ -9548,7 +9548,7 @@
               <a:buNone/>
               <a:defRPr sz="2025" b="1">
                 <a:solidFill>
-                  <a:srgbClr val="81D9D1"/>
+                  <a:srgbClr val="007F83"/>
                 </a:solidFill>
                 <a:latin typeface="Arial Unicode MS"/>
                 <a:ea typeface="Arial Unicode MS"/>
@@ -9559,7 +9559,7 @@
               <a:buNone/>
               <a:defRPr sz="2025" b="1">
                 <a:solidFill>
-                  <a:srgbClr val="81D9D1"/>
+                  <a:srgbClr val="007F83"/>
                 </a:solidFill>
                 <a:latin typeface="Arial Unicode MS"/>
                 <a:ea typeface="Arial Unicode MS"/>
@@ -9570,7 +9570,7 @@
               <a:buNone/>
               <a:defRPr sz="2025" b="1">
                 <a:solidFill>
-                  <a:srgbClr val="81D9D1"/>
+                  <a:srgbClr val="007F83"/>
                 </a:solidFill>
                 <a:latin typeface="Arial Unicode MS"/>
                 <a:ea typeface="Arial Unicode MS"/>
@@ -9581,7 +9581,7 @@
               <a:buNone/>
               <a:defRPr sz="2025" b="1">
                 <a:solidFill>
-                  <a:srgbClr val="81D9D1"/>
+                  <a:srgbClr val="007F83"/>
                 </a:solidFill>
                 <a:latin typeface="Arial Unicode MS"/>
                 <a:ea typeface="Arial Unicode MS"/>
@@ -9594,7 +9594,7 @@
               <a:buNone/>
               <a:defRPr sz="2025" b="1">
                 <a:solidFill>
-                  <a:srgbClr val="81D9D1"/>
+                  <a:srgbClr val="007F83"/>
                 </a:solidFill>
                 <a:latin typeface="Arial Unicode MS"/>
                 <a:ea typeface="Arial Unicode MS"/>
@@ -9604,7 +9604,7 @@
             <a:r>
               <a:rPr sz="2025" b="1">
                 <a:solidFill>
-                  <a:srgbClr val="81D9D1"/>
+                  <a:srgbClr val="007F83"/>
                 </a:solidFill>
                 <a:latin typeface="Arial Unicode MS"/>
                 <a:ea typeface="Arial Unicode MS"/>
@@ -9650,7 +9650,7 @@
             <a:defPPr algn="l">
               <a:defRPr sz="1725" b="0">
                 <a:solidFill>
-                  <a:srgbClr val="DCEAF1"/>
+                  <a:srgbClr val="203849"/>
                 </a:solidFill>
                 <a:latin typeface="Arial Unicode MS"/>
                 <a:ea typeface="Arial Unicode MS"/>
@@ -9661,7 +9661,7 @@
               <a:buNone/>
               <a:defRPr sz="1725" b="0">
                 <a:solidFill>
-                  <a:srgbClr val="DCEAF1"/>
+                  <a:srgbClr val="203849"/>
                 </a:solidFill>
                 <a:latin typeface="Arial Unicode MS"/>
                 <a:ea typeface="Arial Unicode MS"/>
@@ -9672,7 +9672,7 @@
               <a:buNone/>
               <a:defRPr sz="1725" b="0">
                 <a:solidFill>
-                  <a:srgbClr val="DCEAF1"/>
+                  <a:srgbClr val="203849"/>
                 </a:solidFill>
                 <a:latin typeface="Arial Unicode MS"/>
                 <a:ea typeface="Arial Unicode MS"/>
@@ -9683,7 +9683,7 @@
               <a:buNone/>
               <a:defRPr sz="1725" b="0">
                 <a:solidFill>
-                  <a:srgbClr val="DCEAF1"/>
+                  <a:srgbClr val="203849"/>
                 </a:solidFill>
                 <a:latin typeface="Arial Unicode MS"/>
                 <a:ea typeface="Arial Unicode MS"/>
@@ -9694,7 +9694,7 @@
               <a:buNone/>
               <a:defRPr sz="1725" b="0">
                 <a:solidFill>
-                  <a:srgbClr val="DCEAF1"/>
+                  <a:srgbClr val="203849"/>
                 </a:solidFill>
                 <a:latin typeface="Arial Unicode MS"/>
                 <a:ea typeface="Arial Unicode MS"/>
@@ -9705,7 +9705,7 @@
               <a:buNone/>
               <a:defRPr sz="1725" b="0">
                 <a:solidFill>
-                  <a:srgbClr val="DCEAF1"/>
+                  <a:srgbClr val="203849"/>
                 </a:solidFill>
                 <a:latin typeface="Arial Unicode MS"/>
                 <a:ea typeface="Arial Unicode MS"/>
@@ -9716,7 +9716,7 @@
               <a:buNone/>
               <a:defRPr sz="1725" b="0">
                 <a:solidFill>
-                  <a:srgbClr val="DCEAF1"/>
+                  <a:srgbClr val="203849"/>
                 </a:solidFill>
                 <a:latin typeface="Arial Unicode MS"/>
                 <a:ea typeface="Arial Unicode MS"/>
@@ -9727,7 +9727,7 @@
               <a:buNone/>
               <a:defRPr sz="1725" b="0">
                 <a:solidFill>
-                  <a:srgbClr val="DCEAF1"/>
+                  <a:srgbClr val="203849"/>
                 </a:solidFill>
                 <a:latin typeface="Arial Unicode MS"/>
                 <a:ea typeface="Arial Unicode MS"/>
@@ -9738,7 +9738,7 @@
               <a:buNone/>
               <a:defRPr sz="1725" b="0">
                 <a:solidFill>
-                  <a:srgbClr val="DCEAF1"/>
+                  <a:srgbClr val="203849"/>
                 </a:solidFill>
                 <a:latin typeface="Arial Unicode MS"/>
                 <a:ea typeface="Arial Unicode MS"/>
@@ -9749,7 +9749,7 @@
               <a:buNone/>
               <a:defRPr sz="1725" b="0">
                 <a:solidFill>
-                  <a:srgbClr val="DCEAF1"/>
+                  <a:srgbClr val="203849"/>
                 </a:solidFill>
                 <a:latin typeface="Arial Unicode MS"/>
                 <a:ea typeface="Arial Unicode MS"/>
@@ -9762,7 +9762,7 @@
               <a:buNone/>
               <a:defRPr sz="1725" b="0">
                 <a:solidFill>
-                  <a:srgbClr val="DCEAF1"/>
+                  <a:srgbClr val="203849"/>
                 </a:solidFill>
                 <a:latin typeface="Arial Unicode MS"/>
                 <a:ea typeface="Arial Unicode MS"/>
@@ -9772,7 +9772,7 @@
             <a:r>
               <a:rPr sz="1725" b="0">
                 <a:solidFill>
-                  <a:srgbClr val="DCEAF1"/>
+                  <a:srgbClr val="203849"/>
                 </a:solidFill>
                 <a:latin typeface="Arial Unicode MS"/>
                 <a:ea typeface="Arial Unicode MS"/>
@@ -9786,7 +9786,7 @@
               <a:buNone/>
               <a:defRPr sz="1725" b="0">
                 <a:solidFill>
-                  <a:srgbClr val="DCEAF1"/>
+                  <a:srgbClr val="203849"/>
                 </a:solidFill>
                 <a:latin typeface="Arial Unicode MS"/>
                 <a:ea typeface="Arial Unicode MS"/>
@@ -9796,7 +9796,7 @@
             <a:r>
               <a:rPr sz="1725" b="0">
                 <a:solidFill>
-                  <a:srgbClr val="DCEAF1"/>
+                  <a:srgbClr val="203849"/>
                 </a:solidFill>
                 <a:latin typeface="Arial Unicode MS"/>
                 <a:ea typeface="Arial Unicode MS"/>
@@ -9842,7 +9842,7 @@
             <a:defPPr algn="l">
               <a:defRPr sz="2025" b="1">
                 <a:solidFill>
-                  <a:srgbClr val="EEC28B"/>
+                  <a:srgbClr val="9A641E"/>
                 </a:solidFill>
                 <a:latin typeface="Arial Unicode MS"/>
                 <a:ea typeface="Arial Unicode MS"/>
@@ -9853,7 +9853,7 @@
               <a:buNone/>
               <a:defRPr sz="2025" b="1">
                 <a:solidFill>
-                  <a:srgbClr val="EEC28B"/>
+                  <a:srgbClr val="9A641E"/>
                 </a:solidFill>
                 <a:latin typeface="Arial Unicode MS"/>
                 <a:ea typeface="Arial Unicode MS"/>
@@ -9864,7 +9864,7 @@
               <a:buNone/>
               <a:defRPr sz="2025" b="1">
                 <a:solidFill>
-                  <a:srgbClr val="EEC28B"/>
+                  <a:srgbClr val="9A641E"/>
                 </a:solidFill>
                 <a:latin typeface="Arial Unicode MS"/>
                 <a:ea typeface="Arial Unicode MS"/>
@@ -9875,7 +9875,7 @@
               <a:buNone/>
               <a:defRPr sz="2025" b="1">
                 <a:solidFill>
-                  <a:srgbClr val="EEC28B"/>
+                  <a:srgbClr val="9A641E"/>
                 </a:solidFill>
                 <a:latin typeface="Arial Unicode MS"/>
                 <a:ea typeface="Arial Unicode MS"/>
@@ -9886,7 +9886,7 @@
               <a:buNone/>
               <a:defRPr sz="2025" b="1">
                 <a:solidFill>
-                  <a:srgbClr val="EEC28B"/>
+                  <a:srgbClr val="9A641E"/>
                 </a:solidFill>
                 <a:latin typeface="Arial Unicode MS"/>
                 <a:ea typeface="Arial Unicode MS"/>
@@ -9897,7 +9897,7 @@
               <a:buNone/>
               <a:defRPr sz="2025" b="1">
                 <a:solidFill>
-                  <a:srgbClr val="EEC28B"/>
+                  <a:srgbClr val="9A641E"/>
                 </a:solidFill>
                 <a:latin typeface="Arial Unicode MS"/>
                 <a:ea typeface="Arial Unicode MS"/>
@@ -9908,7 +9908,7 @@
               <a:buNone/>
               <a:defRPr sz="2025" b="1">
                 <a:solidFill>
-                  <a:srgbClr val="EEC28B"/>
+                  <a:srgbClr val="9A641E"/>
                 </a:solidFill>
                 <a:latin typeface="Arial Unicode MS"/>
                 <a:ea typeface="Arial Unicode MS"/>
@@ -9919,7 +9919,7 @@
               <a:buNone/>
               <a:defRPr sz="2025" b="1">
                 <a:solidFill>
-                  <a:srgbClr val="EEC28B"/>
+                  <a:srgbClr val="9A641E"/>
                 </a:solidFill>
                 <a:latin typeface="Arial Unicode MS"/>
                 <a:ea typeface="Arial Unicode MS"/>
@@ -9930,7 +9930,7 @@
               <a:buNone/>
               <a:defRPr sz="2025" b="1">
                 <a:solidFill>
-                  <a:srgbClr val="EEC28B"/>
+                  <a:srgbClr val="9A641E"/>
                 </a:solidFill>
                 <a:latin typeface="Arial Unicode MS"/>
                 <a:ea typeface="Arial Unicode MS"/>
@@ -9941,7 +9941,7 @@
               <a:buNone/>
               <a:defRPr sz="2025" b="1">
                 <a:solidFill>
-                  <a:srgbClr val="EEC28B"/>
+                  <a:srgbClr val="9A641E"/>
                 </a:solidFill>
                 <a:latin typeface="Arial Unicode MS"/>
                 <a:ea typeface="Arial Unicode MS"/>
@@ -9954,7 +9954,7 @@
               <a:buNone/>
               <a:defRPr sz="2025" b="1">
                 <a:solidFill>
-                  <a:srgbClr val="EEC28B"/>
+                  <a:srgbClr val="9A641E"/>
                 </a:solidFill>
                 <a:latin typeface="Arial Unicode MS"/>
                 <a:ea typeface="Arial Unicode MS"/>
@@ -9964,7 +9964,7 @@
             <a:r>
               <a:rPr sz="2025" b="1">
                 <a:solidFill>
-                  <a:srgbClr val="EEC28B"/>
+                  <a:srgbClr val="9A641E"/>
                 </a:solidFill>
                 <a:latin typeface="Arial Unicode MS"/>
                 <a:ea typeface="Arial Unicode MS"/>
@@ -10010,7 +10010,7 @@
             <a:defPPr algn="l">
               <a:defRPr sz="1725" b="0">
                 <a:solidFill>
-                  <a:srgbClr val="DCEAF1"/>
+                  <a:srgbClr val="203849"/>
                 </a:solidFill>
                 <a:latin typeface="Arial Unicode MS"/>
                 <a:ea typeface="Arial Unicode MS"/>
@@ -10021,7 +10021,7 @@
               <a:buNone/>
               <a:defRPr sz="1725" b="0">
                 <a:solidFill>
-                  <a:srgbClr val="DCEAF1"/>
+                  <a:srgbClr val="203849"/>
                 </a:solidFill>
                 <a:latin typeface="Arial Unicode MS"/>
                 <a:ea typeface="Arial Unicode MS"/>
@@ -10032,7 +10032,7 @@
               <a:buNone/>
               <a:defRPr sz="1725" b="0">
                 <a:solidFill>
-                  <a:srgbClr val="DCEAF1"/>
+                  <a:srgbClr val="203849"/>
                 </a:solidFill>
                 <a:latin typeface="Arial Unicode MS"/>
                 <a:ea typeface="Arial Unicode MS"/>
@@ -10043,7 +10043,7 @@
               <a:buNone/>
               <a:defRPr sz="1725" b="0">
                 <a:solidFill>
-                  <a:srgbClr val="DCEAF1"/>
+                  <a:srgbClr val="203849"/>
                 </a:solidFill>
                 <a:latin typeface="Arial Unicode MS"/>
                 <a:ea typeface="Arial Unicode MS"/>
@@ -10054,7 +10054,7 @@
               <a:buNone/>
               <a:defRPr sz="1725" b="0">
                 <a:solidFill>
-                  <a:srgbClr val="DCEAF1"/>
+                  <a:srgbClr val="203849"/>
                 </a:solidFill>
                 <a:latin typeface="Arial Unicode MS"/>
                 <a:ea typeface="Arial Unicode MS"/>
@@ -10065,7 +10065,7 @@
               <a:buNone/>
               <a:defRPr sz="1725" b="0">
                 <a:solidFill>
-                  <a:srgbClr val="DCEAF1"/>
+                  <a:srgbClr val="203849"/>
                 </a:solidFill>
                 <a:latin typeface="Arial Unicode MS"/>
                 <a:ea typeface="Arial Unicode MS"/>
@@ -10076,7 +10076,7 @@
               <a:buNone/>
               <a:defRPr sz="1725" b="0">
                 <a:solidFill>
-                  <a:srgbClr val="DCEAF1"/>
+                  <a:srgbClr val="203849"/>
                 </a:solidFill>
                 <a:latin typeface="Arial Unicode MS"/>
                 <a:ea typeface="Arial Unicode MS"/>
@@ -10087,7 +10087,7 @@
               <a:buNone/>
               <a:defRPr sz="1725" b="0">
                 <a:solidFill>
-                  <a:srgbClr val="DCEAF1"/>
+                  <a:srgbClr val="203849"/>
                 </a:solidFill>
                 <a:latin typeface="Arial Unicode MS"/>
                 <a:ea typeface="Arial Unicode MS"/>
@@ -10098,7 +10098,7 @@
               <a:buNone/>
               <a:defRPr sz="1725" b="0">
                 <a:solidFill>
-                  <a:srgbClr val="DCEAF1"/>
+                  <a:srgbClr val="203849"/>
                 </a:solidFill>
                 <a:latin typeface="Arial Unicode MS"/>
                 <a:ea typeface="Arial Unicode MS"/>
@@ -10109,7 +10109,7 @@
               <a:buNone/>
               <a:defRPr sz="1725" b="0">
                 <a:solidFill>
-                  <a:srgbClr val="DCEAF1"/>
+                  <a:srgbClr val="203849"/>
                 </a:solidFill>
                 <a:latin typeface="Arial Unicode MS"/>
                 <a:ea typeface="Arial Unicode MS"/>
@@ -10122,7 +10122,7 @@
               <a:buNone/>
               <a:defRPr sz="1725" b="0">
                 <a:solidFill>
-                  <a:srgbClr val="DCEAF1"/>
+                  <a:srgbClr val="203849"/>
                 </a:solidFill>
                 <a:latin typeface="Arial Unicode MS"/>
                 <a:ea typeface="Arial Unicode MS"/>
@@ -10132,7 +10132,7 @@
             <a:r>
               <a:rPr sz="1725" b="0">
                 <a:solidFill>
-                  <a:srgbClr val="DCEAF1"/>
+                  <a:srgbClr val="203849"/>
                 </a:solidFill>
                 <a:latin typeface="Arial Unicode MS"/>
                 <a:ea typeface="Arial Unicode MS"/>
@@ -10165,7 +10165,7 @@
           </a:prstGeom>
           <a:ln xmlns:a="http://schemas.openxmlformats.org/drawingml/2006/main" w="9525">
             <a:solidFill>
-              <a:srgbClr val="587386"/>
+              <a:srgbClr val="9BADB8"/>
             </a:solidFill>
             <a:tailEnd type="none" w="sm" len="sm"/>
           </a:ln>
@@ -10206,7 +10206,7 @@
             <a:defPPr algn="l">
               <a:defRPr sz="2025" b="1">
                 <a:solidFill>
-                  <a:srgbClr val="81D9D1"/>
+                  <a:srgbClr val="007F83"/>
                 </a:solidFill>
                 <a:latin typeface="Arial Unicode MS"/>
                 <a:ea typeface="Arial Unicode MS"/>
@@ -10217,7 +10217,7 @@
               <a:buNone/>
               <a:defRPr sz="2025" b="1">
                 <a:solidFill>
-                  <a:srgbClr val="81D9D1"/>
+                  <a:srgbClr val="007F83"/>
                 </a:solidFill>
                 <a:latin typeface="Arial Unicode MS"/>
                 <a:ea typeface="Arial Unicode MS"/>
@@ -10228,7 +10228,7 @@
               <a:buNone/>
               <a:defRPr sz="2025" b="1">
                 <a:solidFill>
-                  <a:srgbClr val="81D9D1"/>
+                  <a:srgbClr val="007F83"/>
                 </a:solidFill>
                 <a:latin typeface="Arial Unicode MS"/>
                 <a:ea typeface="Arial Unicode MS"/>
@@ -10239,7 +10239,7 @@
               <a:buNone/>
               <a:defRPr sz="2025" b="1">
                 <a:solidFill>
-                  <a:srgbClr val="81D9D1"/>
+                  <a:srgbClr val="007F83"/>
                 </a:solidFill>
                 <a:latin typeface="Arial Unicode MS"/>
                 <a:ea typeface="Arial Unicode MS"/>
@@ -10250,7 +10250,7 @@
               <a:buNone/>
               <a:defRPr sz="2025" b="1">
                 <a:solidFill>
-                  <a:srgbClr val="81D9D1"/>
+                  <a:srgbClr val="007F83"/>
                 </a:solidFill>
                 <a:latin typeface="Arial Unicode MS"/>
                 <a:ea typeface="Arial Unicode MS"/>
@@ -10261,7 +10261,7 @@
               <a:buNone/>
               <a:defRPr sz="2025" b="1">
                 <a:solidFill>
-                  <a:srgbClr val="81D9D1"/>
+                  <a:srgbClr val="007F83"/>
                 </a:solidFill>
                 <a:latin typeface="Arial Unicode MS"/>
                 <a:ea typeface="Arial Unicode MS"/>
@@ -10272,7 +10272,7 @@
               <a:buNone/>
               <a:defRPr sz="2025" b="1">
                 <a:solidFill>
-                  <a:srgbClr val="81D9D1"/>
+                  <a:srgbClr val="007F83"/>
                 </a:solidFill>
                 <a:latin typeface="Arial Unicode MS"/>
                 <a:ea typeface="Arial Unicode MS"/>
@@ -10283,7 +10283,7 @@
               <a:buNone/>
               <a:defRPr sz="2025" b="1">
                 <a:solidFill>
-                  <a:srgbClr val="81D9D1"/>
+                  <a:srgbClr val="007F83"/>
                 </a:solidFill>
                 <a:latin typeface="Arial Unicode MS"/>
                 <a:ea typeface="Arial Unicode MS"/>
@@ -10294,7 +10294,7 @@
               <a:buNone/>
               <a:defRPr sz="2025" b="1">
                 <a:solidFill>
-                  <a:srgbClr val="81D9D1"/>
+                  <a:srgbClr val="007F83"/>
                 </a:solidFill>
                 <a:latin typeface="Arial Unicode MS"/>
                 <a:ea typeface="Arial Unicode MS"/>
@@ -10305,7 +10305,7 @@
               <a:buNone/>
               <a:defRPr sz="2025" b="1">
                 <a:solidFill>
-                  <a:srgbClr val="81D9D1"/>
+                  <a:srgbClr val="007F83"/>
                 </a:solidFill>
                 <a:latin typeface="Arial Unicode MS"/>
                 <a:ea typeface="Arial Unicode MS"/>
@@ -10318,7 +10318,7 @@
               <a:buNone/>
               <a:defRPr sz="2025" b="1">
                 <a:solidFill>
-                  <a:srgbClr val="81D9D1"/>
+                  <a:srgbClr val="007F83"/>
                 </a:solidFill>
                 <a:latin typeface="Arial Unicode MS"/>
                 <a:ea typeface="Arial Unicode MS"/>
@@ -10328,7 +10328,7 @@
             <a:r>
               <a:rPr sz="2025" b="1">
                 <a:solidFill>
-                  <a:srgbClr val="81D9D1"/>
+                  <a:srgbClr val="007F83"/>
                 </a:solidFill>
                 <a:latin typeface="Arial Unicode MS"/>
                 <a:ea typeface="Arial Unicode MS"/>
@@ -10374,7 +10374,7 @@
             <a:defPPr algn="l">
               <a:defRPr sz="1725" b="0">
                 <a:solidFill>
-                  <a:srgbClr val="DCEAF1"/>
+                  <a:srgbClr val="203849"/>
                 </a:solidFill>
                 <a:latin typeface="Arial Unicode MS"/>
                 <a:ea typeface="Arial Unicode MS"/>
@@ -10385,7 +10385,7 @@
               <a:buNone/>
               <a:defRPr sz="1725" b="0">
                 <a:solidFill>
-                  <a:srgbClr val="DCEAF1"/>
+                  <a:srgbClr val="203849"/>
                 </a:solidFill>
                 <a:latin typeface="Arial Unicode MS"/>
                 <a:ea typeface="Arial Unicode MS"/>
@@ -10396,7 +10396,7 @@
               <a:buNone/>
               <a:defRPr sz="1725" b="0">
                 <a:solidFill>
-                  <a:srgbClr val="DCEAF1"/>
+                  <a:srgbClr val="203849"/>
                 </a:solidFill>
                 <a:latin typeface="Arial Unicode MS"/>
                 <a:ea typeface="Arial Unicode MS"/>
@@ -10407,7 +10407,7 @@
               <a:buNone/>
               <a:defRPr sz="1725" b="0">
                 <a:solidFill>
-                  <a:srgbClr val="DCEAF1"/>
+                  <a:srgbClr val="203849"/>
                 </a:solidFill>
                 <a:latin typeface="Arial Unicode MS"/>
                 <a:ea typeface="Arial Unicode MS"/>
@@ -10418,7 +10418,7 @@
               <a:buNone/>
               <a:defRPr sz="1725" b="0">
                 <a:solidFill>
-                  <a:srgbClr val="DCEAF1"/>
+                  <a:srgbClr val="203849"/>
                 </a:solidFill>
                 <a:latin typeface="Arial Unicode MS"/>
                 <a:ea typeface="Arial Unicode MS"/>
@@ -10429,7 +10429,7 @@
               <a:buNone/>
               <a:defRPr sz="1725" b="0">
                 <a:solidFill>
-                  <a:srgbClr val="DCEAF1"/>
+                  <a:srgbClr val="203849"/>
                 </a:solidFill>
                 <a:latin typeface="Arial Unicode MS"/>
                 <a:ea typeface="Arial Unicode MS"/>
@@ -10440,7 +10440,7 @@
               <a:buNone/>
               <a:defRPr sz="1725" b="0">
                 <a:solidFill>
-                  <a:srgbClr val="DCEAF1"/>
+                  <a:srgbClr val="203849"/>
                 </a:solidFill>
                 <a:latin typeface="Arial Unicode MS"/>
                 <a:ea typeface="Arial Unicode MS"/>
@@ -10451,7 +10451,7 @@
               <a:buNone/>
               <a:defRPr sz="1725" b="0">
                 <a:solidFill>
-                  <a:srgbClr val="DCEAF1"/>
+                  <a:srgbClr val="203849"/>
                 </a:solidFill>
                 <a:latin typeface="Arial Unicode MS"/>
                 <a:ea typeface="Arial Unicode MS"/>
@@ -10462,7 +10462,7 @@
               <a:buNone/>
               <a:defRPr sz="1725" b="0">
                 <a:solidFill>
-                  <a:srgbClr val="DCEAF1"/>
+                  <a:srgbClr val="203849"/>
                 </a:solidFill>
                 <a:latin typeface="Arial Unicode MS"/>
                 <a:ea typeface="Arial Unicode MS"/>
@@ -10473,7 +10473,7 @@
               <a:buNone/>
               <a:defRPr sz="1725" b="0">
                 <a:solidFill>
-                  <a:srgbClr val="DCEAF1"/>
+                  <a:srgbClr val="203849"/>
                 </a:solidFill>
                 <a:latin typeface="Arial Unicode MS"/>
                 <a:ea typeface="Arial Unicode MS"/>
@@ -10486,7 +10486,7 @@
               <a:buNone/>
               <a:defRPr sz="1725" b="0">
                 <a:solidFill>
-                  <a:srgbClr val="DCEAF1"/>
+                  <a:srgbClr val="203849"/>
                 </a:solidFill>
                 <a:latin typeface="Arial Unicode MS"/>
                 <a:ea typeface="Arial Unicode MS"/>
@@ -10496,7 +10496,7 @@
             <a:r>
               <a:rPr sz="1725" b="0">
                 <a:solidFill>
-                  <a:srgbClr val="DCEAF1"/>
+                  <a:srgbClr val="203849"/>
                 </a:solidFill>
                 <a:latin typeface="Arial Unicode MS"/>
                 <a:ea typeface="Arial Unicode MS"/>
@@ -10510,7 +10510,7 @@
               <a:buNone/>
               <a:defRPr sz="1725" b="0">
                 <a:solidFill>
-                  <a:srgbClr val="DCEAF1"/>
+                  <a:srgbClr val="203849"/>
                 </a:solidFill>
                 <a:latin typeface="Arial Unicode MS"/>
                 <a:ea typeface="Arial Unicode MS"/>
@@ -10520,7 +10520,7 @@
             <a:r>
               <a:rPr sz="1725" b="0">
                 <a:solidFill>
-                  <a:srgbClr val="DCEAF1"/>
+                  <a:srgbClr val="203849"/>
                 </a:solidFill>
                 <a:latin typeface="Arial Unicode MS"/>
                 <a:ea typeface="Arial Unicode MS"/>
@@ -10566,7 +10566,7 @@
             <a:defPPr algn="l">
               <a:defRPr sz="1950" b="0">
                 <a:solidFill>
-                  <a:srgbClr val="FFFFFF"/>
+                  <a:srgbClr val="102C43"/>
                 </a:solidFill>
                 <a:latin typeface="Arial Unicode MS"/>
                 <a:ea typeface="Arial Unicode MS"/>
@@ -10577,7 +10577,7 @@
               <a:buNone/>
               <a:defRPr sz="1950" b="0">
                 <a:solidFill>
-                  <a:srgbClr val="FFFFFF"/>
+                  <a:srgbClr val="102C43"/>
                 </a:solidFill>
                 <a:latin typeface="Arial Unicode MS"/>
                 <a:ea typeface="Arial Unicode MS"/>
@@ -10588,7 +10588,7 @@
               <a:buNone/>
               <a:defRPr sz="1950" b="0">
                 <a:solidFill>
-                  <a:srgbClr val="FFFFFF"/>
+                  <a:srgbClr val="102C43"/>
                 </a:solidFill>
                 <a:latin typeface="Arial Unicode MS"/>
                 <a:ea typeface="Arial Unicode MS"/>
@@ -10599,7 +10599,7 @@
               <a:buNone/>
               <a:defRPr sz="1950" b="0">
                 <a:solidFill>
-                  <a:srgbClr val="FFFFFF"/>
+                  <a:srgbClr val="102C43"/>
                 </a:solidFill>
                 <a:latin typeface="Arial Unicode MS"/>
                 <a:ea typeface="Arial Unicode MS"/>
@@ -10610,7 +10610,7 @@
               <a:buNone/>
               <a:defRPr sz="1950" b="0">
                 <a:solidFill>
-                  <a:srgbClr val="FFFFFF"/>
+                  <a:srgbClr val="102C43"/>
                 </a:solidFill>
                 <a:latin typeface="Arial Unicode MS"/>
                 <a:ea typeface="Arial Unicode MS"/>
@@ -10621,7 +10621,7 @@
               <a:buNone/>
               <a:defRPr sz="1950" b="0">
                 <a:solidFill>
-                  <a:srgbClr val="FFFFFF"/>
+                  <a:srgbClr val="102C43"/>
                 </a:solidFill>
                 <a:latin typeface="Arial Unicode MS"/>
                 <a:ea typeface="Arial Unicode MS"/>
@@ -10632,7 +10632,7 @@
               <a:buNone/>
               <a:defRPr sz="1950" b="0">
                 <a:solidFill>
-                  <a:srgbClr val="FFFFFF"/>
+                  <a:srgbClr val="102C43"/>
                 </a:solidFill>
                 <a:latin typeface="Arial Unicode MS"/>
                 <a:ea typeface="Arial Unicode MS"/>
@@ -10643,7 +10643,7 @@
               <a:buNone/>
               <a:defRPr sz="1950" b="0">
                 <a:solidFill>
-                  <a:srgbClr val="FFFFFF"/>
+                  <a:srgbClr val="102C43"/>
                 </a:solidFill>
                 <a:latin typeface="Arial Unicode MS"/>
                 <a:ea typeface="Arial Unicode MS"/>
@@ -10654,7 +10654,7 @@
               <a:buNone/>
               <a:defRPr sz="1950" b="0">
                 <a:solidFill>
-                  <a:srgbClr val="FFFFFF"/>
+                  <a:srgbClr val="102C43"/>
                 </a:solidFill>
                 <a:latin typeface="Arial Unicode MS"/>
                 <a:ea typeface="Arial Unicode MS"/>
@@ -10665,7 +10665,7 @@
               <a:buNone/>
               <a:defRPr sz="1950" b="0">
                 <a:solidFill>
-                  <a:srgbClr val="FFFFFF"/>
+                  <a:srgbClr val="102C43"/>
                 </a:solidFill>
                 <a:latin typeface="Arial Unicode MS"/>
                 <a:ea typeface="Arial Unicode MS"/>
@@ -10678,7 +10678,7 @@
               <a:buNone/>
               <a:defRPr sz="1950" b="0">
                 <a:solidFill>
-                  <a:srgbClr val="FFFFFF"/>
+                  <a:srgbClr val="102C43"/>
                 </a:solidFill>
                 <a:latin typeface="Arial Unicode MS"/>
                 <a:ea typeface="Arial Unicode MS"/>
@@ -10688,7 +10688,7 @@
             <a:r>
               <a:rPr sz="1950" b="0">
                 <a:solidFill>
-                  <a:srgbClr val="FFFFFF"/>
+                  <a:srgbClr val="102C43"/>
                 </a:solidFill>
                 <a:latin typeface="Arial Unicode MS"/>
                 <a:ea typeface="Arial Unicode MS"/>
@@ -10734,7 +10734,7 @@
             <a:defPPr algn="l">
               <a:defRPr sz="1350" b="0">
                 <a:solidFill>
-                  <a:srgbClr val="ADC2D0"/>
+                  <a:srgbClr val="566B79"/>
                 </a:solidFill>
                 <a:latin typeface="Arial Unicode MS"/>
                 <a:ea typeface="Arial Unicode MS"/>
@@ -10745,7 +10745,7 @@
               <a:buNone/>
               <a:defRPr sz="1350" b="0">
                 <a:solidFill>
-                  <a:srgbClr val="ADC2D0"/>
+                  <a:srgbClr val="566B79"/>
                 </a:solidFill>
                 <a:latin typeface="Arial Unicode MS"/>
                 <a:ea typeface="Arial Unicode MS"/>
@@ -10756,7 +10756,7 @@
               <a:buNone/>
               <a:defRPr sz="1350" b="0">
                 <a:solidFill>
-                  <a:srgbClr val="ADC2D0"/>
+                  <a:srgbClr val="566B79"/>
                 </a:solidFill>
                 <a:latin typeface="Arial Unicode MS"/>
                 <a:ea typeface="Arial Unicode MS"/>
@@ -10767,7 +10767,7 @@
               <a:buNone/>
               <a:defRPr sz="1350" b="0">
                 <a:solidFill>
-                  <a:srgbClr val="ADC2D0"/>
+                  <a:srgbClr val="566B79"/>
                 </a:solidFill>
                 <a:latin typeface="Arial Unicode MS"/>
                 <a:ea typeface="Arial Unicode MS"/>
@@ -10778,7 +10778,7 @@
               <a:buNone/>
               <a:defRPr sz="1350" b="0">
                 <a:solidFill>
-                  <a:srgbClr val="ADC2D0"/>
+                  <a:srgbClr val="566B79"/>
                 </a:solidFill>
                 <a:latin typeface="Arial Unicode MS"/>
                 <a:ea typeface="Arial Unicode MS"/>
@@ -10789,7 +10789,7 @@
               <a:buNone/>
               <a:defRPr sz="1350" b="0">
                 <a:solidFill>
-                  <a:srgbClr val="ADC2D0"/>
+                  <a:srgbClr val="566B79"/>
                 </a:solidFill>
                 <a:latin typeface="Arial Unicode MS"/>
                 <a:ea typeface="Arial Unicode MS"/>
@@ -10800,7 +10800,7 @@
               <a:buNone/>
               <a:defRPr sz="1350" b="0">
                 <a:solidFill>
-                  <a:srgbClr val="ADC2D0"/>
+                  <a:srgbClr val="566B79"/>
                 </a:solidFill>
                 <a:latin typeface="Arial Unicode MS"/>
                 <a:ea typeface="Arial Unicode MS"/>
@@ -10811,7 +10811,7 @@
               <a:buNone/>
               <a:defRPr sz="1350" b="0">
                 <a:solidFill>
-                  <a:srgbClr val="ADC2D0"/>
+                  <a:srgbClr val="566B79"/>
                 </a:solidFill>
                 <a:latin typeface="Arial Unicode MS"/>
                 <a:ea typeface="Arial Unicode MS"/>
@@ -10822,7 +10822,7 @@
               <a:buNone/>
               <a:defRPr sz="1350" b="0">
                 <a:solidFill>
-                  <a:srgbClr val="ADC2D0"/>
+                  <a:srgbClr val="566B79"/>
                 </a:solidFill>
                 <a:latin typeface="Arial Unicode MS"/>
                 <a:ea typeface="Arial Unicode MS"/>
@@ -10833,7 +10833,7 @@
               <a:buNone/>
               <a:defRPr sz="1350" b="0">
                 <a:solidFill>
-                  <a:srgbClr val="ADC2D0"/>
+                  <a:srgbClr val="566B79"/>
                 </a:solidFill>
                 <a:latin typeface="Arial Unicode MS"/>
                 <a:ea typeface="Arial Unicode MS"/>
@@ -10846,7 +10846,7 @@
               <a:buNone/>
               <a:defRPr sz="1350" b="0">
                 <a:solidFill>
-                  <a:srgbClr val="ADC2D0"/>
+                  <a:srgbClr val="566B79"/>
                 </a:solidFill>
                 <a:latin typeface="Arial Unicode MS"/>
                 <a:ea typeface="Arial Unicode MS"/>
@@ -10856,7 +10856,7 @@
             <a:r>
               <a:rPr sz="1350" b="0">
                 <a:solidFill>
-                  <a:srgbClr val="ADC2D0"/>
+                  <a:srgbClr val="566B79"/>
                 </a:solidFill>
                 <a:latin typeface="Arial Unicode MS"/>
                 <a:ea typeface="Arial Unicode MS"/>
@@ -10902,7 +10902,7 @@
             <a:defPPr algn="r">
               <a:defRPr sz="1425" b="0">
                 <a:solidFill>
-                  <a:srgbClr val="ADC2D0"/>
+                  <a:srgbClr val="566B79"/>
                 </a:solidFill>
                 <a:latin typeface="Arial Unicode MS"/>
                 <a:ea typeface="Arial Unicode MS"/>
@@ -10913,7 +10913,7 @@
               <a:buNone/>
               <a:defRPr sz="1425" b="0">
                 <a:solidFill>
-                  <a:srgbClr val="ADC2D0"/>
+                  <a:srgbClr val="566B79"/>
                 </a:solidFill>
                 <a:latin typeface="Arial Unicode MS"/>
                 <a:ea typeface="Arial Unicode MS"/>
@@ -10924,7 +10924,7 @@
               <a:buNone/>
               <a:defRPr sz="1425" b="0">
                 <a:solidFill>
-                  <a:srgbClr val="ADC2D0"/>
+                  <a:srgbClr val="566B79"/>
                 </a:solidFill>
                 <a:latin typeface="Arial Unicode MS"/>
                 <a:ea typeface="Arial Unicode MS"/>
@@ -10935,7 +10935,7 @@
               <a:buNone/>
               <a:defRPr sz="1425" b="0">
                 <a:solidFill>
-                  <a:srgbClr val="ADC2D0"/>
+                  <a:srgbClr val="566B79"/>
                 </a:solidFill>
                 <a:latin typeface="Arial Unicode MS"/>
                 <a:ea typeface="Arial Unicode MS"/>
@@ -10946,7 +10946,7 @@
               <a:buNone/>
               <a:defRPr sz="1425" b="0">
                 <a:solidFill>
-                  <a:srgbClr val="ADC2D0"/>
+                  <a:srgbClr val="566B79"/>
                 </a:solidFill>
                 <a:latin typeface="Arial Unicode MS"/>
                 <a:ea typeface="Arial Unicode MS"/>
@@ -10957,7 +10957,7 @@
               <a:buNone/>
               <a:defRPr sz="1425" b="0">
                 <a:solidFill>
-                  <a:srgbClr val="ADC2D0"/>
+                  <a:srgbClr val="566B79"/>
                 </a:solidFill>
                 <a:latin typeface="Arial Unicode MS"/>
                 <a:ea typeface="Arial Unicode MS"/>
@@ -10968,7 +10968,7 @@
               <a:buNone/>
               <a:defRPr sz="1425" b="0">
                 <a:solidFill>
-                  <a:srgbClr val="ADC2D0"/>
+                  <a:srgbClr val="566B79"/>
                 </a:solidFill>
                 <a:latin typeface="Arial Unicode MS"/>
                 <a:ea typeface="Arial Unicode MS"/>
@@ -10979,7 +10979,7 @@
               <a:buNone/>
               <a:defRPr sz="1425" b="0">
                 <a:solidFill>
-                  <a:srgbClr val="ADC2D0"/>
+                  <a:srgbClr val="566B79"/>
                 </a:solidFill>
                 <a:latin typeface="Arial Unicode MS"/>
                 <a:ea typeface="Arial Unicode MS"/>
@@ -10990,7 +10990,7 @@
               <a:buNone/>
               <a:defRPr sz="1425" b="0">
                 <a:solidFill>
-                  <a:srgbClr val="ADC2D0"/>
+                  <a:srgbClr val="566B79"/>
                 </a:solidFill>
                 <a:latin typeface="Arial Unicode MS"/>
                 <a:ea typeface="Arial Unicode MS"/>
@@ -11001,7 +11001,7 @@
               <a:buNone/>
               <a:defRPr sz="1425" b="0">
                 <a:solidFill>
-                  <a:srgbClr val="ADC2D0"/>
+                  <a:srgbClr val="566B79"/>
                 </a:solidFill>
                 <a:latin typeface="Arial Unicode MS"/>
                 <a:ea typeface="Arial Unicode MS"/>
@@ -11014,7 +11014,7 @@
               <a:buNone/>
               <a:defRPr sz="1425" b="0">
                 <a:solidFill>
-                  <a:srgbClr val="ADC2D0"/>
+                  <a:srgbClr val="566B79"/>
                 </a:solidFill>
                 <a:latin typeface="Arial Unicode MS"/>
                 <a:ea typeface="Arial Unicode MS"/>
@@ -11024,7 +11024,7 @@
             <a:r>
               <a:rPr sz="1425" b="0">
                 <a:solidFill>
-                  <a:srgbClr val="ADC2D0"/>
+                  <a:srgbClr val="566B79"/>
                 </a:solidFill>
                 <a:latin typeface="Arial Unicode MS"/>
                 <a:ea typeface="Arial Unicode MS"/>

</xml_diff>